<commit_message>
Update contributors slide: add Sukamal Maity, rename handles, show AI-assisted commits
- Renamed AmanDeepSrivastava19 → "Aman Deep" throughout
- Renamed hkhardeep9 → "Hardeep" throughout
- Added Sukamal Maity (@SukamalMaity) as 5th contributor:
  Product strategy, UX review, accessibility requirements, QA sign-off
- Aman Deep: 10 commits shown as 3 solo + 7 with Claude AI co-author
  (v5.0 biometric, v7.0 redesign, v8.0 mic/biometric, all PPT/docs)
- File ownership table: added "AI-assisted" column per file (✦ Claude vs solo)
- Legend: "Aman Deep prompted and directed; Claude Sonnet 4.6 co-authored"
- Top KPI bar now shows 5 Team Members
- Added 5th repo stat (team size) alongside files/tests/lines

Co-Authored-By: Claude Sonnet 4.6 <noreply@anthropic.com>
</commit_message>
<xml_diff>
--- a/presentation/Saral-Business-Deck.pptx
+++ b/presentation/Saral-Business-Deck.pptx
@@ -12831,7 +12831,7 @@
         <p:spPr>
           <a:xfrm>
             <a:off x="347472" y="1572768"/>
-            <a:ext cx="2761488" cy="1188720"/>
+            <a:ext cx="2249424" cy="1188720"/>
           </a:xfrm>
           <a:prstGeom prst="rect">
             <a:avLst/>
@@ -12874,7 +12874,164 @@
         <p:spPr>
           <a:xfrm>
             <a:off x="347472" y="1572768"/>
-            <a:ext cx="2761488" cy="54864"/>
+            <a:ext cx="2249424" cy="54864"/>
+          </a:xfrm>
+          <a:prstGeom prst="rect">
+            <a:avLst/>
+          </a:prstGeom>
+          <a:solidFill>
+            <a:srgbClr val="AB47BC"/>
+          </a:solidFill>
+          <a:ln>
+            <a:noFill/>
+          </a:ln>
+        </p:spPr>
+        <p:style>
+          <a:lnRef idx="1">
+            <a:schemeClr val="accent1"/>
+          </a:lnRef>
+          <a:fillRef idx="3">
+            <a:schemeClr val="accent1"/>
+          </a:fillRef>
+          <a:effectRef idx="2">
+            <a:schemeClr val="accent1"/>
+          </a:effectRef>
+          <a:fontRef idx="minor">
+            <a:schemeClr val="lt1"/>
+          </a:fontRef>
+        </p:style>
+        <p:txBody>
+          <a:bodyPr rtlCol="0" anchor="ctr"/>
+          <a:lstStyle/>
+          <a:p>
+            <a:pPr algn="ctr"/>
+          </a:p>
+        </p:txBody>
+      </p:sp>
+      <p:sp>
+        <p:nvSpPr>
+          <p:cNvPr id="8" name="TextBox 7"/>
+          <p:cNvSpPr txBox="1"/>
+          <p:nvPr/>
+        </p:nvSpPr>
+        <p:spPr>
+          <a:xfrm>
+            <a:off x="347472" y="1682496"/>
+            <a:ext cx="2249424" cy="640080"/>
+          </a:xfrm>
+          <a:prstGeom prst="rect">
+            <a:avLst/>
+          </a:prstGeom>
+          <a:noFill/>
+        </p:spPr>
+        <p:txBody>
+          <a:bodyPr wrap="square">
+            <a:spAutoFit/>
+          </a:bodyPr>
+          <a:lstStyle/>
+          <a:p>
+            <a:pPr algn="ctr"/>
+            <a:r>
+              <a:rPr sz="3000" b="1" i="0">
+                <a:solidFill>
+                  <a:srgbClr val="AB47BC"/>
+                </a:solidFill>
+                <a:latin typeface="Calibri"/>
+              </a:rPr>
+              <a:t>5</a:t>
+            </a:r>
+          </a:p>
+        </p:txBody>
+      </p:sp>
+      <p:sp>
+        <p:nvSpPr>
+          <p:cNvPr id="9" name="TextBox 8"/>
+          <p:cNvSpPr txBox="1"/>
+          <p:nvPr/>
+        </p:nvSpPr>
+        <p:spPr>
+          <a:xfrm>
+            <a:off x="347472" y="2304288"/>
+            <a:ext cx="2249424" cy="594360"/>
+          </a:xfrm>
+          <a:prstGeom prst="rect">
+            <a:avLst/>
+          </a:prstGeom>
+          <a:noFill/>
+        </p:spPr>
+        <p:txBody>
+          <a:bodyPr wrap="square">
+            <a:spAutoFit/>
+          </a:bodyPr>
+          <a:lstStyle/>
+          <a:p>
+            <a:pPr algn="ctr"/>
+            <a:r>
+              <a:rPr sz="1050" b="0" i="0">
+                <a:solidFill>
+                  <a:srgbClr val="B2CCE8"/>
+                </a:solidFill>
+                <a:latin typeface="Calibri"/>
+              </a:rPr>
+              <a:t>Team
+Members</a:t>
+            </a:r>
+          </a:p>
+        </p:txBody>
+      </p:sp>
+      <p:sp>
+        <p:nvSpPr>
+          <p:cNvPr id="10" name="Rectangle 9"/>
+          <p:cNvSpPr/>
+          <p:nvPr/>
+        </p:nvSpPr>
+        <p:spPr>
+          <a:xfrm>
+            <a:off x="2670048" y="1572768"/>
+            <a:ext cx="2249424" cy="1188720"/>
+          </a:xfrm>
+          <a:prstGeom prst="rect">
+            <a:avLst/>
+          </a:prstGeom>
+          <a:solidFill>
+            <a:srgbClr val="0E2035"/>
+          </a:solidFill>
+          <a:ln>
+            <a:noFill/>
+          </a:ln>
+        </p:spPr>
+        <p:style>
+          <a:lnRef idx="1">
+            <a:schemeClr val="accent1"/>
+          </a:lnRef>
+          <a:fillRef idx="3">
+            <a:schemeClr val="accent1"/>
+          </a:fillRef>
+          <a:effectRef idx="2">
+            <a:schemeClr val="accent1"/>
+          </a:effectRef>
+          <a:fontRef idx="minor">
+            <a:schemeClr val="lt1"/>
+          </a:fontRef>
+        </p:style>
+        <p:txBody>
+          <a:bodyPr rtlCol="0" anchor="ctr"/>
+          <a:lstStyle/>
+          <a:p>
+            <a:pPr algn="ctr"/>
+          </a:p>
+        </p:txBody>
+      </p:sp>
+      <p:sp>
+        <p:nvSpPr>
+          <p:cNvPr id="11" name="Rectangle 10"/>
+          <p:cNvSpPr/>
+          <p:nvPr/>
+        </p:nvSpPr>
+        <p:spPr>
+          <a:xfrm>
+            <a:off x="2670048" y="1572768"/>
+            <a:ext cx="2249424" cy="54864"/>
           </a:xfrm>
           <a:prstGeom prst="rect">
             <a:avLst/>
@@ -12910,14 +13067,14 @@
       </p:sp>
       <p:sp>
         <p:nvSpPr>
-          <p:cNvPr id="8" name="TextBox 7"/>
-          <p:cNvSpPr txBox="1"/>
-          <p:nvPr/>
-        </p:nvSpPr>
-        <p:spPr>
-          <a:xfrm>
-            <a:off x="347472" y="1682496"/>
-            <a:ext cx="2761488" cy="640080"/>
+          <p:cNvPr id="12" name="TextBox 11"/>
+          <p:cNvSpPr txBox="1"/>
+          <p:nvPr/>
+        </p:nvSpPr>
+        <p:spPr>
+          <a:xfrm>
+            <a:off x="2670048" y="1682496"/>
+            <a:ext cx="2249424" cy="640080"/>
           </a:xfrm>
           <a:prstGeom prst="rect">
             <a:avLst/>
@@ -12945,14 +13102,14 @@
       </p:sp>
       <p:sp>
         <p:nvSpPr>
-          <p:cNvPr id="9" name="TextBox 8"/>
-          <p:cNvSpPr txBox="1"/>
-          <p:nvPr/>
-        </p:nvSpPr>
-        <p:spPr>
-          <a:xfrm>
-            <a:off x="347472" y="2304288"/>
-            <a:ext cx="2761488" cy="594360"/>
+          <p:cNvPr id="13" name="TextBox 12"/>
+          <p:cNvSpPr txBox="1"/>
+          <p:nvPr/>
+        </p:nvSpPr>
+        <p:spPr>
+          <a:xfrm>
+            <a:off x="2670048" y="2304288"/>
+            <a:ext cx="2249424" cy="594360"/>
           </a:xfrm>
           <a:prstGeom prst="rect">
             <a:avLst/>
@@ -12981,14 +13138,14 @@
       </p:sp>
       <p:sp>
         <p:nvSpPr>
-          <p:cNvPr id="10" name="Rectangle 9"/>
+          <p:cNvPr id="14" name="Rectangle 13"/>
           <p:cNvSpPr/>
           <p:nvPr/>
         </p:nvSpPr>
         <p:spPr>
           <a:xfrm>
-            <a:off x="3182112" y="1572768"/>
-            <a:ext cx="2761488" cy="1188720"/>
+            <a:off x="4992624" y="1572768"/>
+            <a:ext cx="2249424" cy="1188720"/>
           </a:xfrm>
           <a:prstGeom prst="rect">
             <a:avLst/>
@@ -13024,14 +13181,14 @@
       </p:sp>
       <p:sp>
         <p:nvSpPr>
-          <p:cNvPr id="11" name="Rectangle 10"/>
+          <p:cNvPr id="15" name="Rectangle 14"/>
           <p:cNvSpPr/>
           <p:nvPr/>
         </p:nvSpPr>
         <p:spPr>
           <a:xfrm>
-            <a:off x="3182112" y="1572768"/>
-            <a:ext cx="2761488" cy="54864"/>
+            <a:off x="4992624" y="1572768"/>
+            <a:ext cx="2249424" cy="54864"/>
           </a:xfrm>
           <a:prstGeom prst="rect">
             <a:avLst/>
@@ -13067,14 +13224,14 @@
       </p:sp>
       <p:sp>
         <p:nvSpPr>
-          <p:cNvPr id="12" name="TextBox 11"/>
-          <p:cNvSpPr txBox="1"/>
-          <p:nvPr/>
-        </p:nvSpPr>
-        <p:spPr>
-          <a:xfrm>
-            <a:off x="3182112" y="1682496"/>
-            <a:ext cx="2761488" cy="640080"/>
+          <p:cNvPr id="16" name="TextBox 15"/>
+          <p:cNvSpPr txBox="1"/>
+          <p:nvPr/>
+        </p:nvSpPr>
+        <p:spPr>
+          <a:xfrm>
+            <a:off x="4992624" y="1682496"/>
+            <a:ext cx="2249424" cy="640080"/>
           </a:xfrm>
           <a:prstGeom prst="rect">
             <a:avLst/>
@@ -13102,14 +13259,14 @@
       </p:sp>
       <p:sp>
         <p:nvSpPr>
-          <p:cNvPr id="13" name="TextBox 12"/>
-          <p:cNvSpPr txBox="1"/>
-          <p:nvPr/>
-        </p:nvSpPr>
-        <p:spPr>
-          <a:xfrm>
-            <a:off x="3182112" y="2304288"/>
-            <a:ext cx="2761488" cy="594360"/>
+          <p:cNvPr id="17" name="TextBox 16"/>
+          <p:cNvSpPr txBox="1"/>
+          <p:nvPr/>
+        </p:nvSpPr>
+        <p:spPr>
+          <a:xfrm>
+            <a:off x="4992624" y="2304288"/>
+            <a:ext cx="2249424" cy="594360"/>
           </a:xfrm>
           <a:prstGeom prst="rect">
             <a:avLst/>
@@ -13130,22 +13287,22 @@
                 </a:solidFill>
                 <a:latin typeface="Calibri"/>
               </a:rPr>
-              <a:t>Test files
-439 tests, 0 failures</a:t>
-            </a:r>
-          </a:p>
-        </p:txBody>
-      </p:sp>
-      <p:sp>
-        <p:nvSpPr>
-          <p:cNvPr id="14" name="Rectangle 13"/>
+              <a:t>Test files · 439 tests
+0 failures</a:t>
+            </a:r>
+          </a:p>
+        </p:txBody>
+      </p:sp>
+      <p:sp>
+        <p:nvSpPr>
+          <p:cNvPr id="18" name="Rectangle 17"/>
           <p:cNvSpPr/>
           <p:nvPr/>
         </p:nvSpPr>
         <p:spPr>
           <a:xfrm>
-            <a:off x="6016752" y="1572768"/>
-            <a:ext cx="2761488" cy="1188720"/>
+            <a:off x="7315200" y="1572768"/>
+            <a:ext cx="2249424" cy="1188720"/>
           </a:xfrm>
           <a:prstGeom prst="rect">
             <a:avLst/>
@@ -13181,14 +13338,14 @@
       </p:sp>
       <p:sp>
         <p:nvSpPr>
-          <p:cNvPr id="15" name="Rectangle 14"/>
+          <p:cNvPr id="19" name="Rectangle 18"/>
           <p:cNvSpPr/>
           <p:nvPr/>
         </p:nvSpPr>
         <p:spPr>
           <a:xfrm>
-            <a:off x="6016752" y="1572768"/>
-            <a:ext cx="2761488" cy="54864"/>
+            <a:off x="7315200" y="1572768"/>
+            <a:ext cx="2249424" cy="54864"/>
           </a:xfrm>
           <a:prstGeom prst="rect">
             <a:avLst/>
@@ -13224,14 +13381,14 @@
       </p:sp>
       <p:sp>
         <p:nvSpPr>
-          <p:cNvPr id="16" name="TextBox 15"/>
-          <p:cNvSpPr txBox="1"/>
-          <p:nvPr/>
-        </p:nvSpPr>
-        <p:spPr>
-          <a:xfrm>
-            <a:off x="6016752" y="1682496"/>
-            <a:ext cx="2761488" cy="640080"/>
+          <p:cNvPr id="20" name="TextBox 19"/>
+          <p:cNvSpPr txBox="1"/>
+          <p:nvPr/>
+        </p:nvSpPr>
+        <p:spPr>
+          <a:xfrm>
+            <a:off x="7315200" y="1682496"/>
+            <a:ext cx="2249424" cy="640080"/>
           </a:xfrm>
           <a:prstGeom prst="rect">
             <a:avLst/>
@@ -13259,14 +13416,14 @@
       </p:sp>
       <p:sp>
         <p:nvSpPr>
-          <p:cNvPr id="17" name="TextBox 16"/>
-          <p:cNvSpPr txBox="1"/>
-          <p:nvPr/>
-        </p:nvSpPr>
-        <p:spPr>
-          <a:xfrm>
-            <a:off x="6016752" y="2304288"/>
-            <a:ext cx="2761488" cy="594360"/>
+          <p:cNvPr id="21" name="TextBox 20"/>
+          <p:cNvSpPr txBox="1"/>
+          <p:nvPr/>
+        </p:nvSpPr>
+        <p:spPr>
+          <a:xfrm>
+            <a:off x="7315200" y="2304288"/>
+            <a:ext cx="2249424" cy="594360"/>
           </a:xfrm>
           <a:prstGeom prst="rect">
             <a:avLst/>
@@ -13295,14 +13452,14 @@
       </p:sp>
       <p:sp>
         <p:nvSpPr>
-          <p:cNvPr id="18" name="Rectangle 17"/>
+          <p:cNvPr id="22" name="Rectangle 21"/>
           <p:cNvSpPr/>
           <p:nvPr/>
         </p:nvSpPr>
         <p:spPr>
           <a:xfrm>
-            <a:off x="8851392" y="1572768"/>
-            <a:ext cx="2761488" cy="1188720"/>
+            <a:off x="9637776" y="1572768"/>
+            <a:ext cx="2249424" cy="1188720"/>
           </a:xfrm>
           <a:prstGeom prst="rect">
             <a:avLst/>
@@ -13338,14 +13495,14 @@
       </p:sp>
       <p:sp>
         <p:nvSpPr>
-          <p:cNvPr id="19" name="Rectangle 18"/>
+          <p:cNvPr id="23" name="Rectangle 22"/>
           <p:cNvSpPr/>
           <p:nvPr/>
         </p:nvSpPr>
         <p:spPr>
           <a:xfrm>
-            <a:off x="8851392" y="1572768"/>
-            <a:ext cx="2761488" cy="54864"/>
+            <a:off x="9637776" y="1572768"/>
+            <a:ext cx="2249424" cy="54864"/>
           </a:xfrm>
           <a:prstGeom prst="rect">
             <a:avLst/>
@@ -13381,14 +13538,14 @@
       </p:sp>
       <p:sp>
         <p:nvSpPr>
-          <p:cNvPr id="20" name="TextBox 19"/>
-          <p:cNvSpPr txBox="1"/>
-          <p:nvPr/>
-        </p:nvSpPr>
-        <p:spPr>
-          <a:xfrm>
-            <a:off x="8851392" y="1682496"/>
-            <a:ext cx="2761488" cy="640080"/>
+          <p:cNvPr id="24" name="TextBox 23"/>
+          <p:cNvSpPr txBox="1"/>
+          <p:nvPr/>
+        </p:nvSpPr>
+        <p:spPr>
+          <a:xfrm>
+            <a:off x="9637776" y="1682496"/>
+            <a:ext cx="2249424" cy="640080"/>
           </a:xfrm>
           <a:prstGeom prst="rect">
             <a:avLst/>
@@ -13416,14 +13573,14 @@
       </p:sp>
       <p:sp>
         <p:nvSpPr>
-          <p:cNvPr id="21" name="TextBox 20"/>
-          <p:cNvSpPr txBox="1"/>
-          <p:nvPr/>
-        </p:nvSpPr>
-        <p:spPr>
-          <a:xfrm>
-            <a:off x="8851392" y="2304288"/>
-            <a:ext cx="2761488" cy="594360"/>
+          <p:cNvPr id="25" name="TextBox 24"/>
+          <p:cNvSpPr txBox="1"/>
+          <p:nvPr/>
+        </p:nvSpPr>
+        <p:spPr>
+          <a:xfrm>
+            <a:off x="9637776" y="2304288"/>
+            <a:ext cx="2249424" cy="594360"/>
           </a:xfrm>
           <a:prstGeom prst="rect">
             <a:avLst/>
@@ -13452,14 +13609,14 @@
       </p:sp>
       <p:sp>
         <p:nvSpPr>
-          <p:cNvPr id="22" name="TextBox 21"/>
-          <p:cNvSpPr txBox="1"/>
-          <p:nvPr/>
-        </p:nvSpPr>
-        <p:spPr>
-          <a:xfrm>
-            <a:off x="347472" y="2907792"/>
-            <a:ext cx="5943600" cy="347472"/>
+          <p:cNvPr id="26" name="TextBox 25"/>
+          <p:cNvSpPr txBox="1"/>
+          <p:nvPr/>
+        </p:nvSpPr>
+        <p:spPr>
+          <a:xfrm>
+            <a:off x="347472" y="2852928"/>
+            <a:ext cx="6035040" cy="329184"/>
           </a:xfrm>
           <a:prstGeom prst="rect">
             <a:avLst/>
@@ -13474,7 +13631,7 @@
           <a:p>
             <a:pPr algn="l"/>
             <a:r>
-              <a:rPr sz="1300" b="1" i="0">
+              <a:rPr sz="1250" b="1" i="0">
                 <a:solidFill>
                   <a:srgbClr val="FFFFFF"/>
                 </a:solidFill>
@@ -13487,14 +13644,84 @@
       </p:sp>
       <p:sp>
         <p:nvSpPr>
-          <p:cNvPr id="23" name="Rectangle 22"/>
+          <p:cNvPr id="27" name="TextBox 26"/>
+          <p:cNvSpPr txBox="1"/>
+          <p:nvPr/>
+        </p:nvSpPr>
+        <p:spPr>
+          <a:xfrm>
+            <a:off x="512064" y="3218688"/>
+            <a:ext cx="1371600" cy="201168"/>
+          </a:xfrm>
+          <a:prstGeom prst="rect">
+            <a:avLst/>
+          </a:prstGeom>
+          <a:noFill/>
+        </p:spPr>
+        <p:txBody>
+          <a:bodyPr wrap="square">
+            <a:spAutoFit/>
+          </a:bodyPr>
+          <a:lstStyle/>
+          <a:p>
+            <a:pPr algn="l"/>
+            <a:r>
+              <a:rPr sz="900" b="1" i="0">
+                <a:solidFill>
+                  <a:srgbClr val="B2CCE8"/>
+                </a:solidFill>
+                <a:latin typeface="Calibri"/>
+              </a:rPr>
+              <a:t>Commits</a:t>
+            </a:r>
+          </a:p>
+        </p:txBody>
+      </p:sp>
+      <p:sp>
+        <p:nvSpPr>
+          <p:cNvPr id="28" name="TextBox 27"/>
+          <p:cNvSpPr txBox="1"/>
+          <p:nvPr/>
+        </p:nvSpPr>
+        <p:spPr>
+          <a:xfrm>
+            <a:off x="1097280" y="3218688"/>
+            <a:ext cx="1371600" cy="201168"/>
+          </a:xfrm>
+          <a:prstGeom prst="rect">
+            <a:avLst/>
+          </a:prstGeom>
+          <a:noFill/>
+        </p:spPr>
+        <p:txBody>
+          <a:bodyPr wrap="square">
+            <a:spAutoFit/>
+          </a:bodyPr>
+          <a:lstStyle/>
+          <a:p>
+            <a:pPr algn="l"/>
+            <a:r>
+              <a:rPr sz="900" b="1" i="0">
+                <a:solidFill>
+                  <a:srgbClr val="B2CCE8"/>
+                </a:solidFill>
+                <a:latin typeface="Calibri"/>
+              </a:rPr>
+              <a:t>Name / Role</a:t>
+            </a:r>
+          </a:p>
+        </p:txBody>
+      </p:sp>
+      <p:sp>
+        <p:nvSpPr>
+          <p:cNvPr id="29" name="Rectangle 28"/>
           <p:cNvSpPr/>
           <p:nvPr/>
         </p:nvSpPr>
         <p:spPr>
           <a:xfrm>
-            <a:off x="347472" y="3337560"/>
-            <a:ext cx="5989320" cy="731520"/>
+            <a:off x="347472" y="3438144"/>
+            <a:ext cx="6035040" cy="658368"/>
           </a:xfrm>
           <a:prstGeom prst="rect">
             <a:avLst/>
@@ -13530,14 +13757,14 @@
       </p:sp>
       <p:sp>
         <p:nvSpPr>
-          <p:cNvPr id="24" name="Rectangle 23"/>
+          <p:cNvPr id="30" name="Rectangle 29"/>
           <p:cNvSpPr/>
           <p:nvPr/>
         </p:nvSpPr>
         <p:spPr>
           <a:xfrm>
-            <a:off x="347472" y="3337560"/>
-            <a:ext cx="64008" cy="731520"/>
+            <a:off x="347472" y="3438144"/>
+            <a:ext cx="64008" cy="658368"/>
           </a:xfrm>
           <a:prstGeom prst="rect">
             <a:avLst/>
@@ -13573,14 +13800,14 @@
       </p:sp>
       <p:sp>
         <p:nvSpPr>
-          <p:cNvPr id="25" name="Rectangle 24"/>
+          <p:cNvPr id="31" name="Rectangle 30"/>
           <p:cNvSpPr/>
           <p:nvPr/>
         </p:nvSpPr>
         <p:spPr>
           <a:xfrm>
-            <a:off x="512064" y="3520440"/>
-            <a:ext cx="475488" cy="347472"/>
+            <a:off x="484632" y="3602736"/>
+            <a:ext cx="475488" cy="329184"/>
           </a:xfrm>
           <a:prstGeom prst="rect">
             <a:avLst/>
@@ -13616,14 +13843,14 @@
       </p:sp>
       <p:sp>
         <p:nvSpPr>
-          <p:cNvPr id="26" name="TextBox 25"/>
-          <p:cNvSpPr txBox="1"/>
-          <p:nvPr/>
-        </p:nvSpPr>
-        <p:spPr>
-          <a:xfrm>
-            <a:off x="512064" y="3511296"/>
-            <a:ext cx="475488" cy="347472"/>
+          <p:cNvPr id="32" name="TextBox 31"/>
+          <p:cNvSpPr txBox="1"/>
+          <p:nvPr/>
+        </p:nvSpPr>
+        <p:spPr>
+          <a:xfrm>
+            <a:off x="484632" y="3593592"/>
+            <a:ext cx="475488" cy="329184"/>
           </a:xfrm>
           <a:prstGeom prst="rect">
             <a:avLst/>
@@ -13644,21 +13871,21 @@
                 </a:solidFill>
                 <a:latin typeface="Calibri"/>
               </a:rPr>
-              <a:t>9</a:t>
-            </a:r>
-          </a:p>
-        </p:txBody>
-      </p:sp>
-      <p:sp>
-        <p:nvSpPr>
-          <p:cNvPr id="27" name="TextBox 26"/>
-          <p:cNvSpPr txBox="1"/>
-          <p:nvPr/>
-        </p:nvSpPr>
-        <p:spPr>
-          <a:xfrm>
-            <a:off x="1097280" y="3392424"/>
-            <a:ext cx="5120640" cy="274320"/>
+              <a:t>10</a:t>
+            </a:r>
+          </a:p>
+        </p:txBody>
+      </p:sp>
+      <p:sp>
+        <p:nvSpPr>
+          <p:cNvPr id="33" name="TextBox 32"/>
+          <p:cNvSpPr txBox="1"/>
+          <p:nvPr/>
+        </p:nvSpPr>
+        <p:spPr>
+          <a:xfrm>
+            <a:off x="1078992" y="3474720"/>
+            <a:ext cx="5166360" cy="256032"/>
           </a:xfrm>
           <a:prstGeom prst="rect">
             <a:avLst/>
@@ -13673,27 +13900,27 @@
           <a:p>
             <a:pPr algn="l"/>
             <a:r>
-              <a:rPr sz="1200" b="1" i="0">
+              <a:rPr sz="1150" b="1" i="0">
                 <a:solidFill>
                   <a:srgbClr val="FFFFFF"/>
                 </a:solidFill>
                 <a:latin typeface="Calibri"/>
               </a:rPr>
-              <a:t>Aman Deep Srivastava</a:t>
-            </a:r>
-          </a:p>
-        </p:txBody>
-      </p:sp>
-      <p:sp>
-        <p:nvSpPr>
-          <p:cNvPr id="28" name="TextBox 27"/>
-          <p:cNvSpPr txBox="1"/>
-          <p:nvPr/>
-        </p:nvSpPr>
-        <p:spPr>
-          <a:xfrm>
-            <a:off x="1097280" y="3657600"/>
-            <a:ext cx="2743200" cy="201168"/>
+              <a:t>Aman Deep</a:t>
+            </a:r>
+          </a:p>
+        </p:txBody>
+      </p:sp>
+      <p:sp>
+        <p:nvSpPr>
+          <p:cNvPr id="34" name="TextBox 33"/>
+          <p:cNvSpPr txBox="1"/>
+          <p:nvPr/>
+        </p:nvSpPr>
+        <p:spPr>
+          <a:xfrm>
+            <a:off x="1078992" y="3712464"/>
+            <a:ext cx="5166360" cy="201168"/>
           </a:xfrm>
           <a:prstGeom prst="rect">
             <a:avLst/>
@@ -13708,27 +13935,28 @@
           <a:p>
             <a:pPr algn="l"/>
             <a:r>
-              <a:rPr sz="950" b="0" i="1">
+              <a:rPr sz="850" b="0" i="1">
                 <a:solidFill>
                   <a:srgbClr val="4D9EFF"/>
                 </a:solidFill>
                 <a:latin typeface="Calibri"/>
               </a:rPr>
-              <a:t>@AmanDeepSrivastava19</a:t>
-            </a:r>
-          </a:p>
-        </p:txBody>
-      </p:sp>
-      <p:sp>
-        <p:nvSpPr>
-          <p:cNvPr id="29" name="TextBox 28"/>
-          <p:cNvSpPr txBox="1"/>
-          <p:nvPr/>
-        </p:nvSpPr>
-        <p:spPr>
-          <a:xfrm>
-            <a:off x="1097280" y="3840480"/>
-            <a:ext cx="5120640" cy="329184"/>
+              <a:t>@AmanDeepSrivastava19  ·  10 total  ·  3 solo  ·  7 with Claude AI co-author
+(v5.0 biometric · v7.0 redesign · v8.0 mic/biometric · PPT)</a:t>
+            </a:r>
+          </a:p>
+        </p:txBody>
+      </p:sp>
+      <p:sp>
+        <p:nvSpPr>
+          <p:cNvPr id="35" name="TextBox 34"/>
+          <p:cNvSpPr txBox="1"/>
+          <p:nvPr/>
+        </p:nvSpPr>
+        <p:spPr>
+          <a:xfrm>
+            <a:off x="1078992" y="3895344"/>
+            <a:ext cx="5166360" cy="219456"/>
           </a:xfrm>
           <a:prstGeom prst="rect">
             <a:avLst/>
@@ -13743,28 +13971,28 @@
           <a:p>
             <a:pPr algn="l"/>
             <a:r>
-              <a:rPr sz="950" b="0" i="0">
+              <a:rPr sz="900" b="0" i="0">
                 <a:solidFill>
                   <a:srgbClr val="B2CCE8"/>
                 </a:solidFill>
                 <a:latin typeface="Calibri"/>
               </a:rPr>
-              <a:t>Accessibility v6–v8, biometric, session timeout,
-voice follow-ups, mic bar fix, all PPT &amp; docs</a:t>
-            </a:r>
-          </a:p>
-        </p:txBody>
-      </p:sp>
-      <p:sp>
-        <p:nvSpPr>
-          <p:cNvPr id="30" name="Rectangle 29"/>
+              <a:t>Feature delivery: accessibility redesign, voice follow-ups,
+auto-biometric, fixed mic bar, session timeout, all docs &amp; PPT</a:t>
+            </a:r>
+          </a:p>
+        </p:txBody>
+      </p:sp>
+      <p:sp>
+        <p:nvSpPr>
+          <p:cNvPr id="36" name="Rectangle 35"/>
           <p:cNvSpPr/>
           <p:nvPr/>
         </p:nvSpPr>
         <p:spPr>
           <a:xfrm>
-            <a:off x="347472" y="4142232"/>
-            <a:ext cx="5989320" cy="731520"/>
+            <a:off x="347472" y="4133088"/>
+            <a:ext cx="6035040" cy="658368"/>
           </a:xfrm>
           <a:prstGeom prst="rect">
             <a:avLst/>
@@ -13800,14 +14028,14 @@
       </p:sp>
       <p:sp>
         <p:nvSpPr>
-          <p:cNvPr id="31" name="Rectangle 30"/>
+          <p:cNvPr id="37" name="Rectangle 36"/>
           <p:cNvSpPr/>
           <p:nvPr/>
         </p:nvSpPr>
         <p:spPr>
           <a:xfrm>
-            <a:off x="347472" y="4142232"/>
-            <a:ext cx="64008" cy="731520"/>
+            <a:off x="347472" y="4133088"/>
+            <a:ext cx="64008" cy="658368"/>
           </a:xfrm>
           <a:prstGeom prst="rect">
             <a:avLst/>
@@ -13843,14 +14071,14 @@
       </p:sp>
       <p:sp>
         <p:nvSpPr>
-          <p:cNvPr id="32" name="Rectangle 31"/>
+          <p:cNvPr id="38" name="Rectangle 37"/>
           <p:cNvSpPr/>
           <p:nvPr/>
         </p:nvSpPr>
         <p:spPr>
           <a:xfrm>
-            <a:off x="512064" y="4325112"/>
-            <a:ext cx="475488" cy="347472"/>
+            <a:off x="484632" y="4297680"/>
+            <a:ext cx="475488" cy="329184"/>
           </a:xfrm>
           <a:prstGeom prst="rect">
             <a:avLst/>
@@ -13886,14 +14114,14 @@
       </p:sp>
       <p:sp>
         <p:nvSpPr>
-          <p:cNvPr id="33" name="TextBox 32"/>
-          <p:cNvSpPr txBox="1"/>
-          <p:nvPr/>
-        </p:nvSpPr>
-        <p:spPr>
-          <a:xfrm>
-            <a:off x="512064" y="4315968"/>
-            <a:ext cx="475488" cy="347472"/>
+          <p:cNvPr id="39" name="TextBox 38"/>
+          <p:cNvSpPr txBox="1"/>
+          <p:nvPr/>
+        </p:nvSpPr>
+        <p:spPr>
+          <a:xfrm>
+            <a:off x="484632" y="4288536"/>
+            <a:ext cx="475488" cy="329184"/>
           </a:xfrm>
           <a:prstGeom prst="rect">
             <a:avLst/>
@@ -13921,14 +14149,14 @@
       </p:sp>
       <p:sp>
         <p:nvSpPr>
-          <p:cNvPr id="34" name="TextBox 33"/>
-          <p:cNvSpPr txBox="1"/>
-          <p:nvPr/>
-        </p:nvSpPr>
-        <p:spPr>
-          <a:xfrm>
-            <a:off x="1097280" y="4197096"/>
-            <a:ext cx="5120640" cy="274320"/>
+          <p:cNvPr id="40" name="TextBox 39"/>
+          <p:cNvSpPr txBox="1"/>
+          <p:nvPr/>
+        </p:nvSpPr>
+        <p:spPr>
+          <a:xfrm>
+            <a:off x="1078992" y="4169664"/>
+            <a:ext cx="5166360" cy="256032"/>
           </a:xfrm>
           <a:prstGeom prst="rect">
             <a:avLst/>
@@ -13943,7 +14171,7 @@
           <a:p>
             <a:pPr algn="l"/>
             <a:r>
-              <a:rPr sz="1200" b="1" i="0">
+              <a:rPr sz="1150" b="1" i="0">
                 <a:solidFill>
                   <a:srgbClr val="FFFFFF"/>
                 </a:solidFill>
@@ -13956,14 +14184,14 @@
       </p:sp>
       <p:sp>
         <p:nvSpPr>
-          <p:cNvPr id="35" name="TextBox 34"/>
-          <p:cNvSpPr txBox="1"/>
-          <p:nvPr/>
-        </p:nvSpPr>
-        <p:spPr>
-          <a:xfrm>
-            <a:off x="1097280" y="4462272"/>
-            <a:ext cx="2743200" cy="201168"/>
+          <p:cNvPr id="41" name="TextBox 40"/>
+          <p:cNvSpPr txBox="1"/>
+          <p:nvPr/>
+        </p:nvSpPr>
+        <p:spPr>
+          <a:xfrm>
+            <a:off x="1078992" y="4407408"/>
+            <a:ext cx="5166360" cy="201168"/>
           </a:xfrm>
           <a:prstGeom prst="rect">
             <a:avLst/>
@@ -13978,27 +14206,27 @@
           <a:p>
             <a:pPr algn="l"/>
             <a:r>
-              <a:rPr sz="950" b="0" i="1">
-                <a:solidFill>
-                  <a:srgbClr val="4D9EFF"/>
-                </a:solidFill>
-                <a:latin typeface="Calibri"/>
-              </a:rPr>
-              <a:t>@ArundeepKamboj</a:t>
-            </a:r>
-          </a:p>
-        </p:txBody>
-      </p:sp>
-      <p:sp>
-        <p:nvSpPr>
-          <p:cNvPr id="36" name="TextBox 35"/>
-          <p:cNvSpPr txBox="1"/>
-          <p:nvPr/>
-        </p:nvSpPr>
-        <p:spPr>
-          <a:xfrm>
-            <a:off x="1097280" y="4645152"/>
-            <a:ext cx="5120640" cy="329184"/>
+              <a:rPr sz="850" b="0" i="1">
+                <a:solidFill>
+                  <a:srgbClr val="00BFA5"/>
+                </a:solidFill>
+                <a:latin typeface="Calibri"/>
+              </a:rPr>
+              <a:t>@ArundeepKamboj  ·  14 solo commits</a:t>
+            </a:r>
+          </a:p>
+        </p:txBody>
+      </p:sp>
+      <p:sp>
+        <p:nvSpPr>
+          <p:cNvPr id="42" name="TextBox 41"/>
+          <p:cNvSpPr txBox="1"/>
+          <p:nvPr/>
+        </p:nvSpPr>
+        <p:spPr>
+          <a:xfrm>
+            <a:off x="1078992" y="4590288"/>
+            <a:ext cx="5166360" cy="219456"/>
           </a:xfrm>
           <a:prstGeom prst="rect">
             <a:avLst/>
@@ -14013,28 +14241,28 @@
           <a:p>
             <a:pPr algn="l"/>
             <a:r>
-              <a:rPr sz="950" b="0" i="0">
+              <a:rPr sz="900" b="0" i="0">
                 <a:solidFill>
                   <a:srgbClr val="B2CCE8"/>
                 </a:solidFill>
                 <a:latin typeface="Calibri"/>
               </a:rPr>
-              <a:t>Core architecture, HomeScreen redesign, colour palette,
-unit tests, navigation wiring, v3.0 release</a:t>
-            </a:r>
-          </a:p>
-        </p:txBody>
-      </p:sp>
-      <p:sp>
-        <p:nvSpPr>
-          <p:cNvPr id="37" name="Rectangle 36"/>
+              <a:t>Core architecture, HomeScreen redesign, WCAG colour palette,
+comprehensive unit tests, navigation wiring, v3.0 release</a:t>
+            </a:r>
+          </a:p>
+        </p:txBody>
+      </p:sp>
+      <p:sp>
+        <p:nvSpPr>
+          <p:cNvPr id="43" name="Rectangle 42"/>
           <p:cNvSpPr/>
           <p:nvPr/>
         </p:nvSpPr>
         <p:spPr>
           <a:xfrm>
-            <a:off x="347472" y="4946904"/>
-            <a:ext cx="5989320" cy="731520"/>
+            <a:off x="347472" y="4828032"/>
+            <a:ext cx="6035040" cy="658368"/>
           </a:xfrm>
           <a:prstGeom prst="rect">
             <a:avLst/>
@@ -14070,14 +14298,14 @@
       </p:sp>
       <p:sp>
         <p:nvSpPr>
-          <p:cNvPr id="38" name="Rectangle 37"/>
+          <p:cNvPr id="44" name="Rectangle 43"/>
           <p:cNvSpPr/>
           <p:nvPr/>
         </p:nvSpPr>
         <p:spPr>
           <a:xfrm>
-            <a:off x="347472" y="4946904"/>
-            <a:ext cx="64008" cy="731520"/>
+            <a:off x="347472" y="4828032"/>
+            <a:ext cx="64008" cy="658368"/>
           </a:xfrm>
           <a:prstGeom prst="rect">
             <a:avLst/>
@@ -14113,14 +14341,14 @@
       </p:sp>
       <p:sp>
         <p:nvSpPr>
-          <p:cNvPr id="39" name="Rectangle 38"/>
+          <p:cNvPr id="45" name="Rectangle 44"/>
           <p:cNvSpPr/>
           <p:nvPr/>
         </p:nvSpPr>
         <p:spPr>
           <a:xfrm>
-            <a:off x="512064" y="5129784"/>
-            <a:ext cx="475488" cy="347472"/>
+            <a:off x="484632" y="4992624"/>
+            <a:ext cx="475488" cy="329184"/>
           </a:xfrm>
           <a:prstGeom prst="rect">
             <a:avLst/>
@@ -14156,14 +14384,14 @@
       </p:sp>
       <p:sp>
         <p:nvSpPr>
-          <p:cNvPr id="40" name="TextBox 39"/>
-          <p:cNvSpPr txBox="1"/>
-          <p:nvPr/>
-        </p:nvSpPr>
-        <p:spPr>
-          <a:xfrm>
-            <a:off x="512064" y="5120640"/>
-            <a:ext cx="475488" cy="347472"/>
+          <p:cNvPr id="46" name="TextBox 45"/>
+          <p:cNvSpPr txBox="1"/>
+          <p:nvPr/>
+        </p:nvSpPr>
+        <p:spPr>
+          <a:xfrm>
+            <a:off x="484632" y="4983480"/>
+            <a:ext cx="475488" cy="329184"/>
           </a:xfrm>
           <a:prstGeom prst="rect">
             <a:avLst/>
@@ -14191,14 +14419,14 @@
       </p:sp>
       <p:sp>
         <p:nvSpPr>
-          <p:cNvPr id="41" name="TextBox 40"/>
-          <p:cNvSpPr txBox="1"/>
-          <p:nvPr/>
-        </p:nvSpPr>
-        <p:spPr>
-          <a:xfrm>
-            <a:off x="1097280" y="5001768"/>
-            <a:ext cx="5120640" cy="274320"/>
+          <p:cNvPr id="47" name="TextBox 46"/>
+          <p:cNvSpPr txBox="1"/>
+          <p:nvPr/>
+        </p:nvSpPr>
+        <p:spPr>
+          <a:xfrm>
+            <a:off x="1078992" y="4864608"/>
+            <a:ext cx="5166360" cy="256032"/>
           </a:xfrm>
           <a:prstGeom prst="rect">
             <a:avLst/>
@@ -14213,7 +14441,7 @@
           <a:p>
             <a:pPr algn="l"/>
             <a:r>
-              <a:rPr sz="1200" b="1" i="0">
+              <a:rPr sz="1150" b="1" i="0">
                 <a:solidFill>
                   <a:srgbClr val="FFFFFF"/>
                 </a:solidFill>
@@ -14226,14 +14454,14 @@
       </p:sp>
       <p:sp>
         <p:nvSpPr>
-          <p:cNvPr id="42" name="TextBox 41"/>
-          <p:cNvSpPr txBox="1"/>
-          <p:nvPr/>
-        </p:nvSpPr>
-        <p:spPr>
-          <a:xfrm>
-            <a:off x="1097280" y="5266944"/>
-            <a:ext cx="2743200" cy="201168"/>
+          <p:cNvPr id="48" name="TextBox 47"/>
+          <p:cNvSpPr txBox="1"/>
+          <p:nvPr/>
+        </p:nvSpPr>
+        <p:spPr>
+          <a:xfrm>
+            <a:off x="1078992" y="5102352"/>
+            <a:ext cx="5166360" cy="201168"/>
           </a:xfrm>
           <a:prstGeom prst="rect">
             <a:avLst/>
@@ -14248,27 +14476,27 @@
           <a:p>
             <a:pPr algn="l"/>
             <a:r>
-              <a:rPr sz="950" b="0" i="1">
-                <a:solidFill>
-                  <a:srgbClr val="4D9EFF"/>
-                </a:solidFill>
-                <a:latin typeface="Calibri"/>
-              </a:rPr>
-              <a:t>@SHARMAJAYESH / jayesh sharma</a:t>
-            </a:r>
-          </a:p>
-        </p:txBody>
-      </p:sp>
-      <p:sp>
-        <p:nvSpPr>
-          <p:cNvPr id="43" name="TextBox 42"/>
-          <p:cNvSpPr txBox="1"/>
-          <p:nvPr/>
-        </p:nvSpPr>
-        <p:spPr>
-          <a:xfrm>
-            <a:off x="1097280" y="5449824"/>
-            <a:ext cx="5120640" cy="329184"/>
+              <a:rPr sz="850" b="0" i="1">
+                <a:solidFill>
+                  <a:srgbClr val="FFC107"/>
+                </a:solidFill>
+                <a:latin typeface="Calibri"/>
+              </a:rPr>
+              <a:t>@SHARMAJAYESH  ·  7 solo commits</a:t>
+            </a:r>
+          </a:p>
+        </p:txBody>
+      </p:sp>
+      <p:sp>
+        <p:nvSpPr>
+          <p:cNvPr id="49" name="TextBox 48"/>
+          <p:cNvSpPr txBox="1"/>
+          <p:nvPr/>
+        </p:nvSpPr>
+        <p:spPr>
+          <a:xfrm>
+            <a:off x="1078992" y="5285232"/>
+            <a:ext cx="5166360" cy="219456"/>
           </a:xfrm>
           <a:prstGeom prst="rect">
             <a:avLst/>
@@ -14283,28 +14511,28 @@
           <a:p>
             <a:pPr algn="l"/>
             <a:r>
-              <a:rPr sz="950" b="0" i="0">
+              <a:rPr sz="900" b="0" i="0">
                 <a:solidFill>
                   <a:srgbClr val="B2CCE8"/>
                 </a:solidFill>
                 <a:latin typeface="Calibri"/>
               </a:rPr>
-              <a:t>First prototype + APK, README, initial prompt
-document, first feature demo</a:t>
-            </a:r>
-          </a:p>
-        </p:txBody>
-      </p:sp>
-      <p:sp>
-        <p:nvSpPr>
-          <p:cNvPr id="44" name="Rectangle 43"/>
+              <a:t>First prototype + APK, README, initial prompt document,
+first feature demo for stakeholders</a:t>
+            </a:r>
+          </a:p>
+        </p:txBody>
+      </p:sp>
+      <p:sp>
+        <p:nvSpPr>
+          <p:cNvPr id="50" name="Rectangle 49"/>
           <p:cNvSpPr/>
           <p:nvPr/>
         </p:nvSpPr>
         <p:spPr>
           <a:xfrm>
-            <a:off x="347472" y="5751576"/>
-            <a:ext cx="5989320" cy="731520"/>
+            <a:off x="347472" y="5522976"/>
+            <a:ext cx="6035040" cy="658368"/>
           </a:xfrm>
           <a:prstGeom prst="rect">
             <a:avLst/>
@@ -14340,14 +14568,284 @@
       </p:sp>
       <p:sp>
         <p:nvSpPr>
-          <p:cNvPr id="45" name="Rectangle 44"/>
+          <p:cNvPr id="51" name="Rectangle 50"/>
           <p:cNvSpPr/>
           <p:nvPr/>
         </p:nvSpPr>
         <p:spPr>
           <a:xfrm>
-            <a:off x="347472" y="5751576"/>
-            <a:ext cx="64008" cy="731520"/>
+            <a:off x="347472" y="5522976"/>
+            <a:ext cx="64008" cy="658368"/>
+          </a:xfrm>
+          <a:prstGeom prst="rect">
+            <a:avLst/>
+          </a:prstGeom>
+          <a:solidFill>
+            <a:srgbClr val="AB47BC"/>
+          </a:solidFill>
+          <a:ln>
+            <a:noFill/>
+          </a:ln>
+        </p:spPr>
+        <p:style>
+          <a:lnRef idx="1">
+            <a:schemeClr val="accent1"/>
+          </a:lnRef>
+          <a:fillRef idx="3">
+            <a:schemeClr val="accent1"/>
+          </a:fillRef>
+          <a:effectRef idx="2">
+            <a:schemeClr val="accent1"/>
+          </a:effectRef>
+          <a:fontRef idx="minor">
+            <a:schemeClr val="lt1"/>
+          </a:fontRef>
+        </p:style>
+        <p:txBody>
+          <a:bodyPr rtlCol="0" anchor="ctr"/>
+          <a:lstStyle/>
+          <a:p>
+            <a:pPr algn="ctr"/>
+          </a:p>
+        </p:txBody>
+      </p:sp>
+      <p:sp>
+        <p:nvSpPr>
+          <p:cNvPr id="52" name="Rectangle 51"/>
+          <p:cNvSpPr/>
+          <p:nvPr/>
+        </p:nvSpPr>
+        <p:spPr>
+          <a:xfrm>
+            <a:off x="484632" y="5687568"/>
+            <a:ext cx="475488" cy="329184"/>
+          </a:xfrm>
+          <a:prstGeom prst="rect">
+            <a:avLst/>
+          </a:prstGeom>
+          <a:solidFill>
+            <a:srgbClr val="AB47BC"/>
+          </a:solidFill>
+          <a:ln>
+            <a:noFill/>
+          </a:ln>
+        </p:spPr>
+        <p:style>
+          <a:lnRef idx="1">
+            <a:schemeClr val="accent1"/>
+          </a:lnRef>
+          <a:fillRef idx="3">
+            <a:schemeClr val="accent1"/>
+          </a:fillRef>
+          <a:effectRef idx="2">
+            <a:schemeClr val="accent1"/>
+          </a:effectRef>
+          <a:fontRef idx="minor">
+            <a:schemeClr val="lt1"/>
+          </a:fontRef>
+        </p:style>
+        <p:txBody>
+          <a:bodyPr rtlCol="0" anchor="ctr"/>
+          <a:lstStyle/>
+          <a:p>
+            <a:pPr algn="ctr"/>
+          </a:p>
+        </p:txBody>
+      </p:sp>
+      <p:sp>
+        <p:nvSpPr>
+          <p:cNvPr id="53" name="TextBox 52"/>
+          <p:cNvSpPr txBox="1"/>
+          <p:nvPr/>
+        </p:nvSpPr>
+        <p:spPr>
+          <a:xfrm>
+            <a:off x="484632" y="5678424"/>
+            <a:ext cx="475488" cy="329184"/>
+          </a:xfrm>
+          <a:prstGeom prst="rect">
+            <a:avLst/>
+          </a:prstGeom>
+          <a:noFill/>
+        </p:spPr>
+        <p:txBody>
+          <a:bodyPr wrap="square">
+            <a:spAutoFit/>
+          </a:bodyPr>
+          <a:lstStyle/>
+          <a:p>
+            <a:pPr algn="ctr"/>
+            <a:r>
+              <a:rPr sz="1400" b="1" i="0">
+                <a:solidFill>
+                  <a:srgbClr val="FFFFFF"/>
+                </a:solidFill>
+                <a:latin typeface="Calibri"/>
+              </a:rPr>
+              <a:t>—</a:t>
+            </a:r>
+          </a:p>
+        </p:txBody>
+      </p:sp>
+      <p:sp>
+        <p:nvSpPr>
+          <p:cNvPr id="54" name="TextBox 53"/>
+          <p:cNvSpPr txBox="1"/>
+          <p:nvPr/>
+        </p:nvSpPr>
+        <p:spPr>
+          <a:xfrm>
+            <a:off x="1078992" y="5559552"/>
+            <a:ext cx="5166360" cy="256032"/>
+          </a:xfrm>
+          <a:prstGeom prst="rect">
+            <a:avLst/>
+          </a:prstGeom>
+          <a:noFill/>
+        </p:spPr>
+        <p:txBody>
+          <a:bodyPr wrap="square">
+            <a:spAutoFit/>
+          </a:bodyPr>
+          <a:lstStyle/>
+          <a:p>
+            <a:pPr algn="l"/>
+            <a:r>
+              <a:rPr sz="1150" b="1" i="0">
+                <a:solidFill>
+                  <a:srgbClr val="FFFFFF"/>
+                </a:solidFill>
+                <a:latin typeface="Calibri"/>
+              </a:rPr>
+              <a:t>Sukamal Maity</a:t>
+            </a:r>
+          </a:p>
+        </p:txBody>
+      </p:sp>
+      <p:sp>
+        <p:nvSpPr>
+          <p:cNvPr id="55" name="TextBox 54"/>
+          <p:cNvSpPr txBox="1"/>
+          <p:nvPr/>
+        </p:nvSpPr>
+        <p:spPr>
+          <a:xfrm>
+            <a:off x="1078992" y="5797296"/>
+            <a:ext cx="5166360" cy="201168"/>
+          </a:xfrm>
+          <a:prstGeom prst="rect">
+            <a:avLst/>
+          </a:prstGeom>
+          <a:noFill/>
+        </p:spPr>
+        <p:txBody>
+          <a:bodyPr wrap="square">
+            <a:spAutoFit/>
+          </a:bodyPr>
+          <a:lstStyle/>
+          <a:p>
+            <a:pPr algn="l"/>
+            <a:r>
+              <a:rPr sz="850" b="0" i="1">
+                <a:solidFill>
+                  <a:srgbClr val="AB47BC"/>
+                </a:solidFill>
+                <a:latin typeface="Calibri"/>
+              </a:rPr>
+              <a:t>@SukamalMaity  ·  Product strategy &amp; UX review</a:t>
+            </a:r>
+          </a:p>
+        </p:txBody>
+      </p:sp>
+      <p:sp>
+        <p:nvSpPr>
+          <p:cNvPr id="56" name="TextBox 55"/>
+          <p:cNvSpPr txBox="1"/>
+          <p:nvPr/>
+        </p:nvSpPr>
+        <p:spPr>
+          <a:xfrm>
+            <a:off x="1078992" y="5980176"/>
+            <a:ext cx="5166360" cy="219456"/>
+          </a:xfrm>
+          <a:prstGeom prst="rect">
+            <a:avLst/>
+          </a:prstGeom>
+          <a:noFill/>
+        </p:spPr>
+        <p:txBody>
+          <a:bodyPr wrap="square">
+            <a:spAutoFit/>
+          </a:bodyPr>
+          <a:lstStyle/>
+          <a:p>
+            <a:pPr algn="l"/>
+            <a:r>
+              <a:rPr sz="900" b="0" i="0">
+                <a:solidFill>
+                  <a:srgbClr val="B2CCE8"/>
+                </a:solidFill>
+                <a:latin typeface="Calibri"/>
+              </a:rPr>
+              <a:t>User research, accessibility requirement specification,
+stakeholder presentation, QA sign-off</a:t>
+            </a:r>
+          </a:p>
+        </p:txBody>
+      </p:sp>
+      <p:sp>
+        <p:nvSpPr>
+          <p:cNvPr id="57" name="Rectangle 56"/>
+          <p:cNvSpPr/>
+          <p:nvPr/>
+        </p:nvSpPr>
+        <p:spPr>
+          <a:xfrm>
+            <a:off x="347472" y="6217920"/>
+            <a:ext cx="6035040" cy="658368"/>
+          </a:xfrm>
+          <a:prstGeom prst="rect">
+            <a:avLst/>
+          </a:prstGeom>
+          <a:solidFill>
+            <a:srgbClr val="0E2035"/>
+          </a:solidFill>
+          <a:ln>
+            <a:noFill/>
+          </a:ln>
+        </p:spPr>
+        <p:style>
+          <a:lnRef idx="1">
+            <a:schemeClr val="accent1"/>
+          </a:lnRef>
+          <a:fillRef idx="3">
+            <a:schemeClr val="accent1"/>
+          </a:fillRef>
+          <a:effectRef idx="2">
+            <a:schemeClr val="accent1"/>
+          </a:effectRef>
+          <a:fontRef idx="minor">
+            <a:schemeClr val="lt1"/>
+          </a:fontRef>
+        </p:style>
+        <p:txBody>
+          <a:bodyPr rtlCol="0" anchor="ctr"/>
+          <a:lstStyle/>
+          <a:p>
+            <a:pPr algn="ctr"/>
+          </a:p>
+        </p:txBody>
+      </p:sp>
+      <p:sp>
+        <p:nvSpPr>
+          <p:cNvPr id="58" name="Rectangle 57"/>
+          <p:cNvSpPr/>
+          <p:nvPr/>
+        </p:nvSpPr>
+        <p:spPr>
+          <a:xfrm>
+            <a:off x="347472" y="6217920"/>
+            <a:ext cx="64008" cy="658368"/>
           </a:xfrm>
           <a:prstGeom prst="rect">
             <a:avLst/>
@@ -14383,14 +14881,14 @@
       </p:sp>
       <p:sp>
         <p:nvSpPr>
-          <p:cNvPr id="46" name="Rectangle 45"/>
+          <p:cNvPr id="59" name="Rectangle 58"/>
           <p:cNvSpPr/>
           <p:nvPr/>
         </p:nvSpPr>
         <p:spPr>
           <a:xfrm>
-            <a:off x="512064" y="5934456"/>
-            <a:ext cx="475488" cy="347472"/>
+            <a:off x="484632" y="6382512"/>
+            <a:ext cx="475488" cy="329184"/>
           </a:xfrm>
           <a:prstGeom prst="rect">
             <a:avLst/>
@@ -14426,14 +14924,14 @@
       </p:sp>
       <p:sp>
         <p:nvSpPr>
-          <p:cNvPr id="47" name="TextBox 46"/>
-          <p:cNvSpPr txBox="1"/>
-          <p:nvPr/>
-        </p:nvSpPr>
-        <p:spPr>
-          <a:xfrm>
-            <a:off x="512064" y="5925312"/>
-            <a:ext cx="475488" cy="347472"/>
+          <p:cNvPr id="60" name="TextBox 59"/>
+          <p:cNvSpPr txBox="1"/>
+          <p:nvPr/>
+        </p:nvSpPr>
+        <p:spPr>
+          <a:xfrm>
+            <a:off x="484632" y="6373368"/>
+            <a:ext cx="475488" cy="329184"/>
           </a:xfrm>
           <a:prstGeom prst="rect">
             <a:avLst/>
@@ -14461,14 +14959,14 @@
       </p:sp>
       <p:sp>
         <p:nvSpPr>
-          <p:cNvPr id="48" name="TextBox 47"/>
-          <p:cNvSpPr txBox="1"/>
-          <p:nvPr/>
-        </p:nvSpPr>
-        <p:spPr>
-          <a:xfrm>
-            <a:off x="1097280" y="5806440"/>
-            <a:ext cx="5120640" cy="274320"/>
+          <p:cNvPr id="61" name="TextBox 60"/>
+          <p:cNvSpPr txBox="1"/>
+          <p:nvPr/>
+        </p:nvSpPr>
+        <p:spPr>
+          <a:xfrm>
+            <a:off x="1078992" y="6254496"/>
+            <a:ext cx="5166360" cy="256032"/>
           </a:xfrm>
           <a:prstGeom prst="rect">
             <a:avLst/>
@@ -14483,27 +14981,27 @@
           <a:p>
             <a:pPr algn="l"/>
             <a:r>
-              <a:rPr sz="1200" b="1" i="0">
+              <a:rPr sz="1150" b="1" i="0">
                 <a:solidFill>
                   <a:srgbClr val="FFFFFF"/>
                 </a:solidFill>
                 <a:latin typeface="Calibri"/>
               </a:rPr>
-              <a:t>Hardeep (hkhardeep9)</a:t>
-            </a:r>
-          </a:p>
-        </p:txBody>
-      </p:sp>
-      <p:sp>
-        <p:nvSpPr>
-          <p:cNvPr id="49" name="TextBox 48"/>
-          <p:cNvSpPr txBox="1"/>
-          <p:nvPr/>
-        </p:nvSpPr>
-        <p:spPr>
-          <a:xfrm>
-            <a:off x="1097280" y="6071616"/>
-            <a:ext cx="2743200" cy="201168"/>
+              <a:t>Hardeep</a:t>
+            </a:r>
+          </a:p>
+        </p:txBody>
+      </p:sp>
+      <p:sp>
+        <p:nvSpPr>
+          <p:cNvPr id="62" name="TextBox 61"/>
+          <p:cNvSpPr txBox="1"/>
+          <p:nvPr/>
+        </p:nvSpPr>
+        <p:spPr>
+          <a:xfrm>
+            <a:off x="1078992" y="6492240"/>
+            <a:ext cx="5166360" cy="201168"/>
           </a:xfrm>
           <a:prstGeom prst="rect">
             <a:avLst/>
@@ -14518,27 +15016,27 @@
           <a:p>
             <a:pPr algn="l"/>
             <a:r>
-              <a:rPr sz="950" b="0" i="1">
-                <a:solidFill>
-                  <a:srgbClr val="4D9EFF"/>
-                </a:solidFill>
-                <a:latin typeface="Calibri"/>
-              </a:rPr>
-              <a:t>@hkhardeep9</a:t>
-            </a:r>
-          </a:p>
-        </p:txBody>
-      </p:sp>
-      <p:sp>
-        <p:nvSpPr>
-          <p:cNvPr id="50" name="TextBox 49"/>
-          <p:cNvSpPr txBox="1"/>
-          <p:nvPr/>
-        </p:nvSpPr>
-        <p:spPr>
-          <a:xfrm>
-            <a:off x="1097280" y="6254496"/>
-            <a:ext cx="5120640" cy="329184"/>
+              <a:rPr sz="850" b="0" i="1">
+                <a:solidFill>
+                  <a:srgbClr val="FF6B35"/>
+                </a:solidFill>
+                <a:latin typeface="Calibri"/>
+              </a:rPr>
+              <a:t>@hkhardeep9  ·  2 solo commits</a:t>
+            </a:r>
+          </a:p>
+        </p:txBody>
+      </p:sp>
+      <p:sp>
+        <p:nvSpPr>
+          <p:cNvPr id="63" name="TextBox 62"/>
+          <p:cNvSpPr txBox="1"/>
+          <p:nvPr/>
+        </p:nvSpPr>
+        <p:spPr>
+          <a:xfrm>
+            <a:off x="1078992" y="6675120"/>
+            <a:ext cx="5166360" cy="219456"/>
           </a:xfrm>
           <a:prstGeom prst="rect">
             <a:avLst/>
@@ -14553,27 +15051,27 @@
           <a:p>
             <a:pPr algn="l"/>
             <a:r>
-              <a:rPr sz="950" b="0" i="0">
+              <a:rPr sz="900" b="0" i="0">
                 <a:solidFill>
                   <a:srgbClr val="B2CCE8"/>
                 </a:solidFill>
                 <a:latin typeface="Calibri"/>
               </a:rPr>
-              <a:t>OTP removal, early APK push</a:t>
-            </a:r>
-          </a:p>
-        </p:txBody>
-      </p:sp>
-      <p:sp>
-        <p:nvSpPr>
-          <p:cNvPr id="51" name="TextBox 50"/>
-          <p:cNvSpPr txBox="1"/>
-          <p:nvPr/>
-        </p:nvSpPr>
-        <p:spPr>
-          <a:xfrm>
-            <a:off x="6492240" y="2907792"/>
-            <a:ext cx="5486400" cy="347472"/>
+              <a:t>OTP flow removal, early APK build &amp; distribution</a:t>
+            </a:r>
+          </a:p>
+        </p:txBody>
+      </p:sp>
+      <p:sp>
+        <p:nvSpPr>
+          <p:cNvPr id="64" name="TextBox 63"/>
+          <p:cNvSpPr txBox="1"/>
+          <p:nvPr/>
+        </p:nvSpPr>
+        <p:spPr>
+          <a:xfrm>
+            <a:off x="6565392" y="2852928"/>
+            <a:ext cx="5486400" cy="329184"/>
           </a:xfrm>
           <a:prstGeom prst="rect">
             <a:avLst/>
@@ -14588,7 +15086,7 @@
           <a:p>
             <a:pPr algn="l"/>
             <a:r>
-              <a:rPr sz="1300" b="1" i="0">
+              <a:rPr sz="1250" b="1" i="0">
                 <a:solidFill>
                   <a:srgbClr val="FFFFFF"/>
                 </a:solidFill>
@@ -14601,14 +15099,197 @@
       </p:sp>
       <p:sp>
         <p:nvSpPr>
-          <p:cNvPr id="52" name="Rectangle 51"/>
+          <p:cNvPr id="65" name="Rectangle 64"/>
           <p:cNvSpPr/>
           <p:nvPr/>
         </p:nvSpPr>
         <p:spPr>
           <a:xfrm>
-            <a:off x="6492240" y="3337560"/>
-            <a:ext cx="5577840" cy="256032"/>
+            <a:off x="6565392" y="3218688"/>
+            <a:ext cx="5577840" cy="219456"/>
+          </a:xfrm>
+          <a:prstGeom prst="rect">
+            <a:avLst/>
+          </a:prstGeom>
+          <a:solidFill>
+            <a:srgbClr val="08182E"/>
+          </a:solidFill>
+          <a:ln>
+            <a:noFill/>
+          </a:ln>
+        </p:spPr>
+        <p:style>
+          <a:lnRef idx="1">
+            <a:schemeClr val="accent1"/>
+          </a:lnRef>
+          <a:fillRef idx="3">
+            <a:schemeClr val="accent1"/>
+          </a:fillRef>
+          <a:effectRef idx="2">
+            <a:schemeClr val="accent1"/>
+          </a:effectRef>
+          <a:fontRef idx="minor">
+            <a:schemeClr val="lt1"/>
+          </a:fontRef>
+        </p:style>
+        <p:txBody>
+          <a:bodyPr rtlCol="0" anchor="ctr"/>
+          <a:lstStyle/>
+          <a:p>
+            <a:pPr algn="ctr"/>
+          </a:p>
+        </p:txBody>
+      </p:sp>
+      <p:sp>
+        <p:nvSpPr>
+          <p:cNvPr id="66" name="TextBox 65"/>
+          <p:cNvSpPr txBox="1"/>
+          <p:nvPr/>
+        </p:nvSpPr>
+        <p:spPr>
+          <a:xfrm>
+            <a:off x="6656832" y="3236976"/>
+            <a:ext cx="1097280" cy="182880"/>
+          </a:xfrm>
+          <a:prstGeom prst="rect">
+            <a:avLst/>
+          </a:prstGeom>
+          <a:noFill/>
+        </p:spPr>
+        <p:txBody>
+          <a:bodyPr wrap="square">
+            <a:spAutoFit/>
+          </a:bodyPr>
+          <a:lstStyle/>
+          <a:p>
+            <a:pPr algn="l"/>
+            <a:r>
+              <a:rPr sz="850" b="1" i="0">
+                <a:solidFill>
+                  <a:srgbClr val="B2CCE8"/>
+                </a:solidFill>
+                <a:latin typeface="Calibri"/>
+              </a:rPr>
+              <a:t>File</a:t>
+            </a:r>
+          </a:p>
+        </p:txBody>
+      </p:sp>
+      <p:sp>
+        <p:nvSpPr>
+          <p:cNvPr id="67" name="TextBox 66"/>
+          <p:cNvSpPr txBox="1"/>
+          <p:nvPr/>
+        </p:nvSpPr>
+        <p:spPr>
+          <a:xfrm>
+            <a:off x="9034272" y="3236976"/>
+            <a:ext cx="1097280" cy="182880"/>
+          </a:xfrm>
+          <a:prstGeom prst="rect">
+            <a:avLst/>
+          </a:prstGeom>
+          <a:noFill/>
+        </p:spPr>
+        <p:txBody>
+          <a:bodyPr wrap="square">
+            <a:spAutoFit/>
+          </a:bodyPr>
+          <a:lstStyle/>
+          <a:p>
+            <a:pPr algn="l"/>
+            <a:r>
+              <a:rPr sz="850" b="1" i="0">
+                <a:solidFill>
+                  <a:srgbClr val="B2CCE8"/>
+                </a:solidFill>
+                <a:latin typeface="Calibri"/>
+              </a:rPr>
+              <a:t>Author</a:t>
+            </a:r>
+          </a:p>
+        </p:txBody>
+      </p:sp>
+      <p:sp>
+        <p:nvSpPr>
+          <p:cNvPr id="68" name="TextBox 67"/>
+          <p:cNvSpPr txBox="1"/>
+          <p:nvPr/>
+        </p:nvSpPr>
+        <p:spPr>
+          <a:xfrm>
+            <a:off x="10360152" y="3236976"/>
+            <a:ext cx="1097280" cy="182880"/>
+          </a:xfrm>
+          <a:prstGeom prst="rect">
+            <a:avLst/>
+          </a:prstGeom>
+          <a:noFill/>
+        </p:spPr>
+        <p:txBody>
+          <a:bodyPr wrap="square">
+            <a:spAutoFit/>
+          </a:bodyPr>
+          <a:lstStyle/>
+          <a:p>
+            <a:pPr algn="l"/>
+            <a:r>
+              <a:rPr sz="850" b="1" i="0">
+                <a:solidFill>
+                  <a:srgbClr val="B2CCE8"/>
+                </a:solidFill>
+                <a:latin typeface="Calibri"/>
+              </a:rPr>
+              <a:t>AI-assisted</a:t>
+            </a:r>
+          </a:p>
+        </p:txBody>
+      </p:sp>
+      <p:sp>
+        <p:nvSpPr>
+          <p:cNvPr id="69" name="TextBox 68"/>
+          <p:cNvSpPr txBox="1"/>
+          <p:nvPr/>
+        </p:nvSpPr>
+        <p:spPr>
+          <a:xfrm>
+            <a:off x="11228832" y="3236976"/>
+            <a:ext cx="1097280" cy="182880"/>
+          </a:xfrm>
+          <a:prstGeom prst="rect">
+            <a:avLst/>
+          </a:prstGeom>
+          <a:noFill/>
+        </p:spPr>
+        <p:txBody>
+          <a:bodyPr wrap="square">
+            <a:spAutoFit/>
+          </a:bodyPr>
+          <a:lstStyle/>
+          <a:p>
+            <a:pPr algn="l"/>
+            <a:r>
+              <a:rPr sz="850" b="1" i="0">
+                <a:solidFill>
+                  <a:srgbClr val="B2CCE8"/>
+                </a:solidFill>
+                <a:latin typeface="Calibri"/>
+              </a:rPr>
+              <a:t>Purpose</a:t>
+            </a:r>
+          </a:p>
+        </p:txBody>
+      </p:sp>
+      <p:sp>
+        <p:nvSpPr>
+          <p:cNvPr id="70" name="Rectangle 69"/>
+          <p:cNvSpPr/>
+          <p:nvPr/>
+        </p:nvSpPr>
+        <p:spPr>
+          <a:xfrm>
+            <a:off x="6565392" y="3456432"/>
+            <a:ext cx="5577840" cy="237744"/>
           </a:xfrm>
           <a:prstGeom prst="rect">
             <a:avLst/>
@@ -14644,14 +15325,14 @@
       </p:sp>
       <p:sp>
         <p:nvSpPr>
-          <p:cNvPr id="53" name="TextBox 52"/>
-          <p:cNvSpPr txBox="1"/>
-          <p:nvPr/>
-        </p:nvSpPr>
-        <p:spPr>
-          <a:xfrm>
-            <a:off x="6583680" y="3364992"/>
-            <a:ext cx="2423160" cy="219456"/>
+          <p:cNvPr id="71" name="TextBox 70"/>
+          <p:cNvSpPr txBox="1"/>
+          <p:nvPr/>
+        </p:nvSpPr>
+        <p:spPr>
+          <a:xfrm>
+            <a:off x="6656832" y="3483864"/>
+            <a:ext cx="2331720" cy="201168"/>
           </a:xfrm>
           <a:prstGeom prst="rect">
             <a:avLst/>
@@ -14666,7 +15347,7 @@
           <a:p>
             <a:pPr algn="l"/>
             <a:r>
-              <a:rPr sz="950" b="1" i="0">
+              <a:rPr sz="900" b="1" i="0">
                 <a:solidFill>
                   <a:srgbClr val="FFFFFF"/>
                 </a:solidFill>
@@ -14679,14 +15360,14 @@
       </p:sp>
       <p:sp>
         <p:nvSpPr>
-          <p:cNvPr id="54" name="TextBox 53"/>
-          <p:cNvSpPr txBox="1"/>
-          <p:nvPr/>
-        </p:nvSpPr>
-        <p:spPr>
-          <a:xfrm>
-            <a:off x="9034272" y="3364992"/>
-            <a:ext cx="1417320" cy="219456"/>
+          <p:cNvPr id="72" name="TextBox 71"/>
+          <p:cNvSpPr txBox="1"/>
+          <p:nvPr/>
+        </p:nvSpPr>
+        <p:spPr>
+          <a:xfrm>
+            <a:off x="9034272" y="3483864"/>
+            <a:ext cx="1280160" cy="201168"/>
           </a:xfrm>
           <a:prstGeom prst="rect">
             <a:avLst/>
@@ -14707,36 +15388,71 @@
                 </a:solidFill>
                 <a:latin typeface="Calibri"/>
               </a:rPr>
-              <a:t>@AmanDeepSrivastava19</a:t>
-            </a:r>
-          </a:p>
-        </p:txBody>
-      </p:sp>
-      <p:sp>
-        <p:nvSpPr>
-          <p:cNvPr id="55" name="TextBox 54"/>
-          <p:cNvSpPr txBox="1"/>
-          <p:nvPr/>
-        </p:nvSpPr>
-        <p:spPr>
-          <a:xfrm>
-            <a:off x="10469879" y="3364992"/>
-            <a:ext cx="1572768" cy="219456"/>
-          </a:xfrm>
-          <a:prstGeom prst="rect">
-            <a:avLst/>
-          </a:prstGeom>
-          <a:noFill/>
-        </p:spPr>
-        <p:txBody>
-          <a:bodyPr wrap="none">
+              <a:t>Aman Deep</a:t>
+            </a:r>
+          </a:p>
+        </p:txBody>
+      </p:sp>
+      <p:sp>
+        <p:nvSpPr>
+          <p:cNvPr id="73" name="TextBox 72"/>
+          <p:cNvSpPr txBox="1"/>
+          <p:nvPr/>
+        </p:nvSpPr>
+        <p:spPr>
+          <a:xfrm>
+            <a:off x="10360152" y="3483864"/>
+            <a:ext cx="822960" cy="201168"/>
+          </a:xfrm>
+          <a:prstGeom prst="rect">
+            <a:avLst/>
+          </a:prstGeom>
+          <a:noFill/>
+        </p:spPr>
+        <p:txBody>
+          <a:bodyPr wrap="square">
             <a:spAutoFit/>
           </a:bodyPr>
           <a:lstStyle/>
           <a:p>
             <a:pPr algn="l"/>
             <a:r>
-              <a:rPr sz="850" b="0" i="0">
+              <a:rPr sz="850" b="1" i="0">
+                <a:solidFill>
+                  <a:srgbClr val="FFC107"/>
+                </a:solidFill>
+                <a:latin typeface="Calibri"/>
+              </a:rPr>
+              <a:t>✦ Claude</a:t>
+            </a:r>
+          </a:p>
+        </p:txBody>
+      </p:sp>
+      <p:sp>
+        <p:nvSpPr>
+          <p:cNvPr id="74" name="TextBox 73"/>
+          <p:cNvSpPr txBox="1"/>
+          <p:nvPr/>
+        </p:nvSpPr>
+        <p:spPr>
+          <a:xfrm>
+            <a:off x="11228832" y="3483864"/>
+            <a:ext cx="896112" cy="201168"/>
+          </a:xfrm>
+          <a:prstGeom prst="rect">
+            <a:avLst/>
+          </a:prstGeom>
+          <a:noFill/>
+        </p:spPr>
+        <p:txBody>
+          <a:bodyPr wrap="square">
+            <a:spAutoFit/>
+          </a:bodyPr>
+          <a:lstStyle/>
+          <a:p>
+            <a:pPr algn="l"/>
+            <a:r>
+              <a:rPr sz="750" b="0" i="0">
                 <a:solidFill>
                   <a:srgbClr val="B2CCE8"/>
                 </a:solidFill>
@@ -14749,14 +15465,14 @@
       </p:sp>
       <p:sp>
         <p:nvSpPr>
-          <p:cNvPr id="56" name="Rectangle 55"/>
+          <p:cNvPr id="75" name="Rectangle 74"/>
           <p:cNvSpPr/>
           <p:nvPr/>
         </p:nvSpPr>
         <p:spPr>
           <a:xfrm>
-            <a:off x="6492240" y="3611880"/>
-            <a:ext cx="5577840" cy="256032"/>
+            <a:off x="6565392" y="3703320"/>
+            <a:ext cx="5577840" cy="237744"/>
           </a:xfrm>
           <a:prstGeom prst="rect">
             <a:avLst/>
@@ -14792,14 +15508,14 @@
       </p:sp>
       <p:sp>
         <p:nvSpPr>
-          <p:cNvPr id="57" name="TextBox 56"/>
-          <p:cNvSpPr txBox="1"/>
-          <p:nvPr/>
-        </p:nvSpPr>
-        <p:spPr>
-          <a:xfrm>
-            <a:off x="6583680" y="3639312"/>
-            <a:ext cx="2423160" cy="219456"/>
+          <p:cNvPr id="76" name="TextBox 75"/>
+          <p:cNvSpPr txBox="1"/>
+          <p:nvPr/>
+        </p:nvSpPr>
+        <p:spPr>
+          <a:xfrm>
+            <a:off x="6656832" y="3730752"/>
+            <a:ext cx="2331720" cy="201168"/>
           </a:xfrm>
           <a:prstGeom prst="rect">
             <a:avLst/>
@@ -14814,7 +15530,7 @@
           <a:p>
             <a:pPr algn="l"/>
             <a:r>
-              <a:rPr sz="950" b="1" i="0">
+              <a:rPr sz="900" b="1" i="0">
                 <a:solidFill>
                   <a:srgbClr val="FFFFFF"/>
                 </a:solidFill>
@@ -14827,14 +15543,14 @@
       </p:sp>
       <p:sp>
         <p:nvSpPr>
-          <p:cNvPr id="58" name="TextBox 57"/>
-          <p:cNvSpPr txBox="1"/>
-          <p:nvPr/>
-        </p:nvSpPr>
-        <p:spPr>
-          <a:xfrm>
-            <a:off x="9034272" y="3639312"/>
-            <a:ext cx="1417320" cy="219456"/>
+          <p:cNvPr id="77" name="TextBox 76"/>
+          <p:cNvSpPr txBox="1"/>
+          <p:nvPr/>
+        </p:nvSpPr>
+        <p:spPr>
+          <a:xfrm>
+            <a:off x="9034272" y="3730752"/>
+            <a:ext cx="1280160" cy="201168"/>
           </a:xfrm>
           <a:prstGeom prst="rect">
             <a:avLst/>
@@ -14855,36 +15571,71 @@
                 </a:solidFill>
                 <a:latin typeface="Calibri"/>
               </a:rPr>
-              <a:t>@AmanDeepSrivastava19</a:t>
-            </a:r>
-          </a:p>
-        </p:txBody>
-      </p:sp>
-      <p:sp>
-        <p:nvSpPr>
-          <p:cNvPr id="59" name="TextBox 58"/>
-          <p:cNvSpPr txBox="1"/>
-          <p:nvPr/>
-        </p:nvSpPr>
-        <p:spPr>
-          <a:xfrm>
-            <a:off x="10469879" y="3639312"/>
-            <a:ext cx="1572768" cy="219456"/>
-          </a:xfrm>
-          <a:prstGeom prst="rect">
-            <a:avLst/>
-          </a:prstGeom>
-          <a:noFill/>
-        </p:spPr>
-        <p:txBody>
-          <a:bodyPr wrap="none">
+              <a:t>Aman Deep</a:t>
+            </a:r>
+          </a:p>
+        </p:txBody>
+      </p:sp>
+      <p:sp>
+        <p:nvSpPr>
+          <p:cNvPr id="78" name="TextBox 77"/>
+          <p:cNvSpPr txBox="1"/>
+          <p:nvPr/>
+        </p:nvSpPr>
+        <p:spPr>
+          <a:xfrm>
+            <a:off x="10360152" y="3730752"/>
+            <a:ext cx="822960" cy="201168"/>
+          </a:xfrm>
+          <a:prstGeom prst="rect">
+            <a:avLst/>
+          </a:prstGeom>
+          <a:noFill/>
+        </p:spPr>
+        <p:txBody>
+          <a:bodyPr wrap="square">
             <a:spAutoFit/>
           </a:bodyPr>
           <a:lstStyle/>
           <a:p>
             <a:pPr algn="l"/>
             <a:r>
-              <a:rPr sz="850" b="0" i="0">
+              <a:rPr sz="850" b="1" i="0">
+                <a:solidFill>
+                  <a:srgbClr val="FFC107"/>
+                </a:solidFill>
+                <a:latin typeface="Calibri"/>
+              </a:rPr>
+              <a:t>✦ Claude</a:t>
+            </a:r>
+          </a:p>
+        </p:txBody>
+      </p:sp>
+      <p:sp>
+        <p:nvSpPr>
+          <p:cNvPr id="79" name="TextBox 78"/>
+          <p:cNvSpPr txBox="1"/>
+          <p:nvPr/>
+        </p:nvSpPr>
+        <p:spPr>
+          <a:xfrm>
+            <a:off x="11228832" y="3730752"/>
+            <a:ext cx="896112" cy="201168"/>
+          </a:xfrm>
+          <a:prstGeom prst="rect">
+            <a:avLst/>
+          </a:prstGeom>
+          <a:noFill/>
+        </p:spPr>
+        <p:txBody>
+          <a:bodyPr wrap="square">
+            <a:spAutoFit/>
+          </a:bodyPr>
+          <a:lstStyle/>
+          <a:p>
+            <a:pPr algn="l"/>
+            <a:r>
+              <a:rPr sz="750" b="0" i="0">
                 <a:solidFill>
                   <a:srgbClr val="B2CCE8"/>
                 </a:solidFill>
@@ -14897,14 +15648,14 @@
       </p:sp>
       <p:sp>
         <p:nvSpPr>
-          <p:cNvPr id="60" name="Rectangle 59"/>
+          <p:cNvPr id="80" name="Rectangle 79"/>
           <p:cNvSpPr/>
           <p:nvPr/>
         </p:nvSpPr>
         <p:spPr>
           <a:xfrm>
-            <a:off x="6492240" y="3886200"/>
-            <a:ext cx="5577840" cy="256032"/>
+            <a:off x="6565392" y="3950208"/>
+            <a:ext cx="5577840" cy="237744"/>
           </a:xfrm>
           <a:prstGeom prst="rect">
             <a:avLst/>
@@ -14940,14 +15691,14 @@
       </p:sp>
       <p:sp>
         <p:nvSpPr>
-          <p:cNvPr id="61" name="TextBox 60"/>
-          <p:cNvSpPr txBox="1"/>
-          <p:nvPr/>
-        </p:nvSpPr>
-        <p:spPr>
-          <a:xfrm>
-            <a:off x="6583680" y="3913632"/>
-            <a:ext cx="2423160" cy="219456"/>
+          <p:cNvPr id="81" name="TextBox 80"/>
+          <p:cNvSpPr txBox="1"/>
+          <p:nvPr/>
+        </p:nvSpPr>
+        <p:spPr>
+          <a:xfrm>
+            <a:off x="6656832" y="3977640"/>
+            <a:ext cx="2331720" cy="201168"/>
           </a:xfrm>
           <a:prstGeom prst="rect">
             <a:avLst/>
@@ -14962,7 +15713,7 @@
           <a:p>
             <a:pPr algn="l"/>
             <a:r>
-              <a:rPr sz="950" b="1" i="0">
+              <a:rPr sz="900" b="1" i="0">
                 <a:solidFill>
                   <a:srgbClr val="FFFFFF"/>
                 </a:solidFill>
@@ -14975,14 +15726,14 @@
       </p:sp>
       <p:sp>
         <p:nvSpPr>
-          <p:cNvPr id="62" name="TextBox 61"/>
-          <p:cNvSpPr txBox="1"/>
-          <p:nvPr/>
-        </p:nvSpPr>
-        <p:spPr>
-          <a:xfrm>
-            <a:off x="9034272" y="3913632"/>
-            <a:ext cx="1417320" cy="219456"/>
+          <p:cNvPr id="82" name="TextBox 81"/>
+          <p:cNvSpPr txBox="1"/>
+          <p:nvPr/>
+        </p:nvSpPr>
+        <p:spPr>
+          <a:xfrm>
+            <a:off x="9034272" y="3977640"/>
+            <a:ext cx="1280160" cy="201168"/>
           </a:xfrm>
           <a:prstGeom prst="rect">
             <a:avLst/>
@@ -15003,56 +15754,91 @@
                 </a:solidFill>
                 <a:latin typeface="Calibri"/>
               </a:rPr>
-              <a:t>@AmanDeepSrivastava19</a:t>
-            </a:r>
-          </a:p>
-        </p:txBody>
-      </p:sp>
-      <p:sp>
-        <p:nvSpPr>
-          <p:cNvPr id="63" name="TextBox 62"/>
-          <p:cNvSpPr txBox="1"/>
-          <p:nvPr/>
-        </p:nvSpPr>
-        <p:spPr>
-          <a:xfrm>
-            <a:off x="10469879" y="3913632"/>
-            <a:ext cx="1572768" cy="219456"/>
-          </a:xfrm>
-          <a:prstGeom prst="rect">
-            <a:avLst/>
-          </a:prstGeom>
-          <a:noFill/>
-        </p:spPr>
-        <p:txBody>
-          <a:bodyPr wrap="none">
+              <a:t>Aman Deep</a:t>
+            </a:r>
+          </a:p>
+        </p:txBody>
+      </p:sp>
+      <p:sp>
+        <p:nvSpPr>
+          <p:cNvPr id="83" name="TextBox 82"/>
+          <p:cNvSpPr txBox="1"/>
+          <p:nvPr/>
+        </p:nvSpPr>
+        <p:spPr>
+          <a:xfrm>
+            <a:off x="10360152" y="3977640"/>
+            <a:ext cx="822960" cy="201168"/>
+          </a:xfrm>
+          <a:prstGeom prst="rect">
+            <a:avLst/>
+          </a:prstGeom>
+          <a:noFill/>
+        </p:spPr>
+        <p:txBody>
+          <a:bodyPr wrap="square">
             <a:spAutoFit/>
           </a:bodyPr>
           <a:lstStyle/>
           <a:p>
             <a:pPr algn="l"/>
             <a:r>
-              <a:rPr sz="850" b="0" i="0">
+              <a:rPr sz="850" b="1" i="0">
+                <a:solidFill>
+                  <a:srgbClr val="FFC107"/>
+                </a:solidFill>
+                <a:latin typeface="Calibri"/>
+              </a:rPr>
+              <a:t>✦ Claude</a:t>
+            </a:r>
+          </a:p>
+        </p:txBody>
+      </p:sp>
+      <p:sp>
+        <p:nvSpPr>
+          <p:cNvPr id="84" name="TextBox 83"/>
+          <p:cNvSpPr txBox="1"/>
+          <p:nvPr/>
+        </p:nvSpPr>
+        <p:spPr>
+          <a:xfrm>
+            <a:off x="11228832" y="3977640"/>
+            <a:ext cx="896112" cy="201168"/>
+          </a:xfrm>
+          <a:prstGeom prst="rect">
+            <a:avLst/>
+          </a:prstGeom>
+          <a:noFill/>
+        </p:spPr>
+        <p:txBody>
+          <a:bodyPr wrap="square">
+            <a:spAutoFit/>
+          </a:bodyPr>
+          <a:lstStyle/>
+          <a:p>
+            <a:pPr algn="l"/>
+            <a:r>
+              <a:rPr sz="750" b="0" i="0">
                 <a:solidFill>
                   <a:srgbClr val="B2CCE8"/>
                 </a:solidFill>
                 <a:latin typeface="Calibri"/>
               </a:rPr>
-              <a:t>Fixed mic bar, auto-biometric LaunchedEffect</a:t>
-            </a:r>
-          </a:p>
-        </p:txBody>
-      </p:sp>
-      <p:sp>
-        <p:nvSpPr>
-          <p:cNvPr id="64" name="Rectangle 63"/>
+              <a:t>Fixed mic bar, auto-biometric trigger</a:t>
+            </a:r>
+          </a:p>
+        </p:txBody>
+      </p:sp>
+      <p:sp>
+        <p:nvSpPr>
+          <p:cNvPr id="85" name="Rectangle 84"/>
           <p:cNvSpPr/>
           <p:nvPr/>
         </p:nvSpPr>
         <p:spPr>
           <a:xfrm>
-            <a:off x="6492240" y="4160520"/>
-            <a:ext cx="5577840" cy="256032"/>
+            <a:off x="6565392" y="4197096"/>
+            <a:ext cx="5577840" cy="237744"/>
           </a:xfrm>
           <a:prstGeom prst="rect">
             <a:avLst/>
@@ -15088,14 +15874,14 @@
       </p:sp>
       <p:sp>
         <p:nvSpPr>
-          <p:cNvPr id="65" name="TextBox 64"/>
-          <p:cNvSpPr txBox="1"/>
-          <p:nvPr/>
-        </p:nvSpPr>
-        <p:spPr>
-          <a:xfrm>
-            <a:off x="6583680" y="4187952"/>
-            <a:ext cx="2423160" cy="219456"/>
+          <p:cNvPr id="86" name="TextBox 85"/>
+          <p:cNvSpPr txBox="1"/>
+          <p:nvPr/>
+        </p:nvSpPr>
+        <p:spPr>
+          <a:xfrm>
+            <a:off x="6656832" y="4224528"/>
+            <a:ext cx="2331720" cy="201168"/>
           </a:xfrm>
           <a:prstGeom prst="rect">
             <a:avLst/>
@@ -15110,7 +15896,7 @@
           <a:p>
             <a:pPr algn="l"/>
             <a:r>
-              <a:rPr sz="950" b="1" i="0">
+              <a:rPr sz="900" b="1" i="0">
                 <a:solidFill>
                   <a:srgbClr val="FFFFFF"/>
                 </a:solidFill>
@@ -15123,14 +15909,14 @@
       </p:sp>
       <p:sp>
         <p:nvSpPr>
-          <p:cNvPr id="66" name="TextBox 65"/>
-          <p:cNvSpPr txBox="1"/>
-          <p:nvPr/>
-        </p:nvSpPr>
-        <p:spPr>
-          <a:xfrm>
-            <a:off x="9034272" y="4187952"/>
-            <a:ext cx="1417320" cy="219456"/>
+          <p:cNvPr id="87" name="TextBox 86"/>
+          <p:cNvSpPr txBox="1"/>
+          <p:nvPr/>
+        </p:nvSpPr>
+        <p:spPr>
+          <a:xfrm>
+            <a:off x="9034272" y="4224528"/>
+            <a:ext cx="1280160" cy="201168"/>
           </a:xfrm>
           <a:prstGeom prst="rect">
             <a:avLst/>
@@ -15151,36 +15937,71 @@
                 </a:solidFill>
                 <a:latin typeface="Calibri"/>
               </a:rPr>
-              <a:t>@AmanDeepSrivastava19</a:t>
-            </a:r>
-          </a:p>
-        </p:txBody>
-      </p:sp>
-      <p:sp>
-        <p:nvSpPr>
-          <p:cNvPr id="67" name="TextBox 66"/>
-          <p:cNvSpPr txBox="1"/>
-          <p:nvPr/>
-        </p:nvSpPr>
-        <p:spPr>
-          <a:xfrm>
-            <a:off x="10469879" y="4187952"/>
-            <a:ext cx="1572768" cy="219456"/>
-          </a:xfrm>
-          <a:prstGeom prst="rect">
-            <a:avLst/>
-          </a:prstGeom>
-          <a:noFill/>
-        </p:spPr>
-        <p:txBody>
-          <a:bodyPr wrap="none">
+              <a:t>Aman Deep</a:t>
+            </a:r>
+          </a:p>
+        </p:txBody>
+      </p:sp>
+      <p:sp>
+        <p:nvSpPr>
+          <p:cNvPr id="88" name="TextBox 87"/>
+          <p:cNvSpPr txBox="1"/>
+          <p:nvPr/>
+        </p:nvSpPr>
+        <p:spPr>
+          <a:xfrm>
+            <a:off x="10360152" y="4224528"/>
+            <a:ext cx="822960" cy="201168"/>
+          </a:xfrm>
+          <a:prstGeom prst="rect">
+            <a:avLst/>
+          </a:prstGeom>
+          <a:noFill/>
+        </p:spPr>
+        <p:txBody>
+          <a:bodyPr wrap="square">
             <a:spAutoFit/>
           </a:bodyPr>
           <a:lstStyle/>
           <a:p>
             <a:pPr algn="l"/>
             <a:r>
-              <a:rPr sz="850" b="0" i="0">
+              <a:rPr sz="850" b="1" i="0">
+                <a:solidFill>
+                  <a:srgbClr val="FFC107"/>
+                </a:solidFill>
+                <a:latin typeface="Calibri"/>
+              </a:rPr>
+              <a:t>✦ Claude</a:t>
+            </a:r>
+          </a:p>
+        </p:txBody>
+      </p:sp>
+      <p:sp>
+        <p:nvSpPr>
+          <p:cNvPr id="89" name="TextBox 88"/>
+          <p:cNvSpPr txBox="1"/>
+          <p:nvPr/>
+        </p:nvSpPr>
+        <p:spPr>
+          <a:xfrm>
+            <a:off x="11228832" y="4224528"/>
+            <a:ext cx="896112" cy="201168"/>
+          </a:xfrm>
+          <a:prstGeom prst="rect">
+            <a:avLst/>
+          </a:prstGeom>
+          <a:noFill/>
+        </p:spPr>
+        <p:txBody>
+          <a:bodyPr wrap="square">
+            <a:spAutoFit/>
+          </a:bodyPr>
+          <a:lstStyle/>
+          <a:p>
+            <a:pPr algn="l"/>
+            <a:r>
+              <a:rPr sz="750" b="0" i="0">
                 <a:solidFill>
                   <a:srgbClr val="B2CCE8"/>
                 </a:solidFill>
@@ -15193,14 +16014,14 @@
       </p:sp>
       <p:sp>
         <p:nvSpPr>
-          <p:cNvPr id="68" name="Rectangle 67"/>
+          <p:cNvPr id="90" name="Rectangle 89"/>
           <p:cNvSpPr/>
           <p:nvPr/>
         </p:nvSpPr>
         <p:spPr>
           <a:xfrm>
-            <a:off x="6492240" y="4434840"/>
-            <a:ext cx="5577840" cy="256032"/>
+            <a:off x="6565392" y="4443984"/>
+            <a:ext cx="5577840" cy="237744"/>
           </a:xfrm>
           <a:prstGeom prst="rect">
             <a:avLst/>
@@ -15236,14 +16057,14 @@
       </p:sp>
       <p:sp>
         <p:nvSpPr>
-          <p:cNvPr id="69" name="TextBox 68"/>
-          <p:cNvSpPr txBox="1"/>
-          <p:nvPr/>
-        </p:nvSpPr>
-        <p:spPr>
-          <a:xfrm>
-            <a:off x="6583680" y="4462272"/>
-            <a:ext cx="2423160" cy="219456"/>
+          <p:cNvPr id="91" name="TextBox 90"/>
+          <p:cNvSpPr txBox="1"/>
+          <p:nvPr/>
+        </p:nvSpPr>
+        <p:spPr>
+          <a:xfrm>
+            <a:off x="6656832" y="4471416"/>
+            <a:ext cx="2331720" cy="201168"/>
           </a:xfrm>
           <a:prstGeom prst="rect">
             <a:avLst/>
@@ -15258,7 +16079,7 @@
           <a:p>
             <a:pPr algn="l"/>
             <a:r>
-              <a:rPr sz="950" b="1" i="0">
+              <a:rPr sz="900" b="1" i="0">
                 <a:solidFill>
                   <a:srgbClr val="FFFFFF"/>
                 </a:solidFill>
@@ -15271,14 +16092,14 @@
       </p:sp>
       <p:sp>
         <p:nvSpPr>
-          <p:cNvPr id="70" name="TextBox 69"/>
-          <p:cNvSpPr txBox="1"/>
-          <p:nvPr/>
-        </p:nvSpPr>
-        <p:spPr>
-          <a:xfrm>
-            <a:off x="9034272" y="4462272"/>
-            <a:ext cx="1417320" cy="219456"/>
+          <p:cNvPr id="92" name="TextBox 91"/>
+          <p:cNvSpPr txBox="1"/>
+          <p:nvPr/>
+        </p:nvSpPr>
+        <p:spPr>
+          <a:xfrm>
+            <a:off x="9034272" y="4471416"/>
+            <a:ext cx="1280160" cy="201168"/>
           </a:xfrm>
           <a:prstGeom prst="rect">
             <a:avLst/>
@@ -15299,36 +16120,71 @@
                 </a:solidFill>
                 <a:latin typeface="Calibri"/>
               </a:rPr>
-              <a:t>@AmanDeepSrivastava19</a:t>
-            </a:r>
-          </a:p>
-        </p:txBody>
-      </p:sp>
-      <p:sp>
-        <p:nvSpPr>
-          <p:cNvPr id="71" name="TextBox 70"/>
-          <p:cNvSpPr txBox="1"/>
-          <p:nvPr/>
-        </p:nvSpPr>
-        <p:spPr>
-          <a:xfrm>
-            <a:off x="10469879" y="4462272"/>
-            <a:ext cx="1572768" cy="219456"/>
-          </a:xfrm>
-          <a:prstGeom prst="rect">
-            <a:avLst/>
-          </a:prstGeom>
-          <a:noFill/>
-        </p:spPr>
-        <p:txBody>
-          <a:bodyPr wrap="none">
+              <a:t>Aman Deep</a:t>
+            </a:r>
+          </a:p>
+        </p:txBody>
+      </p:sp>
+      <p:sp>
+        <p:nvSpPr>
+          <p:cNvPr id="93" name="TextBox 92"/>
+          <p:cNvSpPr txBox="1"/>
+          <p:nvPr/>
+        </p:nvSpPr>
+        <p:spPr>
+          <a:xfrm>
+            <a:off x="10360152" y="4471416"/>
+            <a:ext cx="822960" cy="201168"/>
+          </a:xfrm>
+          <a:prstGeom prst="rect">
+            <a:avLst/>
+          </a:prstGeom>
+          <a:noFill/>
+        </p:spPr>
+        <p:txBody>
+          <a:bodyPr wrap="square">
             <a:spAutoFit/>
           </a:bodyPr>
           <a:lstStyle/>
           <a:p>
             <a:pPr algn="l"/>
             <a:r>
-              <a:rPr sz="850" b="0" i="0">
+              <a:rPr sz="850" b="1" i="0">
+                <a:solidFill>
+                  <a:srgbClr val="FFC107"/>
+                </a:solidFill>
+                <a:latin typeface="Calibri"/>
+              </a:rPr>
+              <a:t>✦ Claude</a:t>
+            </a:r>
+          </a:p>
+        </p:txBody>
+      </p:sp>
+      <p:sp>
+        <p:nvSpPr>
+          <p:cNvPr id="94" name="TextBox 93"/>
+          <p:cNvSpPr txBox="1"/>
+          <p:nvPr/>
+        </p:nvSpPr>
+        <p:spPr>
+          <a:xfrm>
+            <a:off x="11228832" y="4471416"/>
+            <a:ext cx="896112" cy="201168"/>
+          </a:xfrm>
+          <a:prstGeom prst="rect">
+            <a:avLst/>
+          </a:prstGeom>
+          <a:noFill/>
+        </p:spPr>
+        <p:txBody>
+          <a:bodyPr wrap="square">
+            <a:spAutoFit/>
+          </a:bodyPr>
+          <a:lstStyle/>
+          <a:p>
+            <a:pPr algn="l"/>
+            <a:r>
+              <a:rPr sz="750" b="0" i="0">
                 <a:solidFill>
                   <a:srgbClr val="B2CCE8"/>
                 </a:solidFill>
@@ -15341,14 +16197,14 @@
       </p:sp>
       <p:sp>
         <p:nvSpPr>
-          <p:cNvPr id="72" name="Rectangle 71"/>
+          <p:cNvPr id="95" name="Rectangle 94"/>
           <p:cNvSpPr/>
           <p:nvPr/>
         </p:nvSpPr>
         <p:spPr>
           <a:xfrm>
-            <a:off x="6492240" y="4709160"/>
-            <a:ext cx="5577840" cy="256032"/>
+            <a:off x="6565392" y="4690872"/>
+            <a:ext cx="5577840" cy="237744"/>
           </a:xfrm>
           <a:prstGeom prst="rect">
             <a:avLst/>
@@ -15384,14 +16240,14 @@
       </p:sp>
       <p:sp>
         <p:nvSpPr>
-          <p:cNvPr id="73" name="TextBox 72"/>
-          <p:cNvSpPr txBox="1"/>
-          <p:nvPr/>
-        </p:nvSpPr>
-        <p:spPr>
-          <a:xfrm>
-            <a:off x="6583680" y="4736592"/>
-            <a:ext cx="2423160" cy="219456"/>
+          <p:cNvPr id="96" name="TextBox 95"/>
+          <p:cNvSpPr txBox="1"/>
+          <p:nvPr/>
+        </p:nvSpPr>
+        <p:spPr>
+          <a:xfrm>
+            <a:off x="6656832" y="4718304"/>
+            <a:ext cx="2331720" cy="201168"/>
           </a:xfrm>
           <a:prstGeom prst="rect">
             <a:avLst/>
@@ -15406,7 +16262,7 @@
           <a:p>
             <a:pPr algn="l"/>
             <a:r>
-              <a:rPr sz="950" b="1" i="0">
+              <a:rPr sz="900" b="1" i="0">
                 <a:solidFill>
                   <a:srgbClr val="FFFFFF"/>
                 </a:solidFill>
@@ -15419,14 +16275,14 @@
       </p:sp>
       <p:sp>
         <p:nvSpPr>
-          <p:cNvPr id="74" name="TextBox 73"/>
-          <p:cNvSpPr txBox="1"/>
-          <p:nvPr/>
-        </p:nvSpPr>
-        <p:spPr>
-          <a:xfrm>
-            <a:off x="9034272" y="4736592"/>
-            <a:ext cx="1417320" cy="219456"/>
+          <p:cNvPr id="97" name="TextBox 96"/>
+          <p:cNvSpPr txBox="1"/>
+          <p:nvPr/>
+        </p:nvSpPr>
+        <p:spPr>
+          <a:xfrm>
+            <a:off x="9034272" y="4718304"/>
+            <a:ext cx="1280160" cy="201168"/>
           </a:xfrm>
           <a:prstGeom prst="rect">
             <a:avLst/>
@@ -15447,36 +16303,71 @@
                 </a:solidFill>
                 <a:latin typeface="Calibri"/>
               </a:rPr>
-              <a:t>@AmanDeepSrivastava19</a:t>
-            </a:r>
-          </a:p>
-        </p:txBody>
-      </p:sp>
-      <p:sp>
-        <p:nvSpPr>
-          <p:cNvPr id="75" name="TextBox 74"/>
-          <p:cNvSpPr txBox="1"/>
-          <p:nvPr/>
-        </p:nvSpPr>
-        <p:spPr>
-          <a:xfrm>
-            <a:off x="10469879" y="4736592"/>
-            <a:ext cx="1572768" cy="219456"/>
-          </a:xfrm>
-          <a:prstGeom prst="rect">
-            <a:avLst/>
-          </a:prstGeom>
-          <a:noFill/>
-        </p:spPr>
-        <p:txBody>
-          <a:bodyPr wrap="none">
+              <a:t>Aman Deep</a:t>
+            </a:r>
+          </a:p>
+        </p:txBody>
+      </p:sp>
+      <p:sp>
+        <p:nvSpPr>
+          <p:cNvPr id="98" name="TextBox 97"/>
+          <p:cNvSpPr txBox="1"/>
+          <p:nvPr/>
+        </p:nvSpPr>
+        <p:spPr>
+          <a:xfrm>
+            <a:off x="10360152" y="4718304"/>
+            <a:ext cx="822960" cy="201168"/>
+          </a:xfrm>
+          <a:prstGeom prst="rect">
+            <a:avLst/>
+          </a:prstGeom>
+          <a:noFill/>
+        </p:spPr>
+        <p:txBody>
+          <a:bodyPr wrap="square">
             <a:spAutoFit/>
           </a:bodyPr>
           <a:lstStyle/>
           <a:p>
             <a:pPr algn="l"/>
             <a:r>
-              <a:rPr sz="850" b="0" i="0">
+              <a:rPr sz="850" b="1" i="0">
+                <a:solidFill>
+                  <a:srgbClr val="FFC107"/>
+                </a:solidFill>
+                <a:latin typeface="Calibri"/>
+              </a:rPr>
+              <a:t>✦ Claude</a:t>
+            </a:r>
+          </a:p>
+        </p:txBody>
+      </p:sp>
+      <p:sp>
+        <p:nvSpPr>
+          <p:cNvPr id="99" name="TextBox 98"/>
+          <p:cNvSpPr txBox="1"/>
+          <p:nvPr/>
+        </p:nvSpPr>
+        <p:spPr>
+          <a:xfrm>
+            <a:off x="11228832" y="4718304"/>
+            <a:ext cx="896112" cy="201168"/>
+          </a:xfrm>
+          <a:prstGeom prst="rect">
+            <a:avLst/>
+          </a:prstGeom>
+          <a:noFill/>
+        </p:spPr>
+        <p:txBody>
+          <a:bodyPr wrap="square">
+            <a:spAutoFit/>
+          </a:bodyPr>
+          <a:lstStyle/>
+          <a:p>
+            <a:pPr algn="l"/>
+            <a:r>
+              <a:rPr sz="750" b="0" i="0">
                 <a:solidFill>
                   <a:srgbClr val="B2CCE8"/>
                 </a:solidFill>
@@ -15489,14 +16380,14 @@
       </p:sp>
       <p:sp>
         <p:nvSpPr>
-          <p:cNvPr id="76" name="Rectangle 75"/>
+          <p:cNvPr id="100" name="Rectangle 99"/>
           <p:cNvSpPr/>
           <p:nvPr/>
         </p:nvSpPr>
         <p:spPr>
           <a:xfrm>
-            <a:off x="6492240" y="4983480"/>
-            <a:ext cx="5577840" cy="256032"/>
+            <a:off x="6565392" y="4937760"/>
+            <a:ext cx="5577840" cy="237744"/>
           </a:xfrm>
           <a:prstGeom prst="rect">
             <a:avLst/>
@@ -15532,14 +16423,14 @@
       </p:sp>
       <p:sp>
         <p:nvSpPr>
-          <p:cNvPr id="77" name="TextBox 76"/>
-          <p:cNvSpPr txBox="1"/>
-          <p:nvPr/>
-        </p:nvSpPr>
-        <p:spPr>
-          <a:xfrm>
-            <a:off x="6583680" y="5010912"/>
-            <a:ext cx="2423160" cy="219456"/>
+          <p:cNvPr id="101" name="TextBox 100"/>
+          <p:cNvSpPr txBox="1"/>
+          <p:nvPr/>
+        </p:nvSpPr>
+        <p:spPr>
+          <a:xfrm>
+            <a:off x="6656832" y="4965192"/>
+            <a:ext cx="2331720" cy="201168"/>
           </a:xfrm>
           <a:prstGeom prst="rect">
             <a:avLst/>
@@ -15554,7 +16445,7 @@
           <a:p>
             <a:pPr algn="l"/>
             <a:r>
-              <a:rPr sz="950" b="1" i="0">
+              <a:rPr sz="900" b="1" i="0">
                 <a:solidFill>
                   <a:srgbClr val="FFFFFF"/>
                 </a:solidFill>
@@ -15567,14 +16458,14 @@
       </p:sp>
       <p:sp>
         <p:nvSpPr>
-          <p:cNvPr id="78" name="TextBox 77"/>
-          <p:cNvSpPr txBox="1"/>
-          <p:nvPr/>
-        </p:nvSpPr>
-        <p:spPr>
-          <a:xfrm>
-            <a:off x="9034272" y="5010912"/>
-            <a:ext cx="1417320" cy="219456"/>
+          <p:cNvPr id="102" name="TextBox 101"/>
+          <p:cNvSpPr txBox="1"/>
+          <p:nvPr/>
+        </p:nvSpPr>
+        <p:spPr>
+          <a:xfrm>
+            <a:off x="9034272" y="4965192"/>
+            <a:ext cx="1280160" cy="201168"/>
           </a:xfrm>
           <a:prstGeom prst="rect">
             <a:avLst/>
@@ -15595,36 +16486,71 @@
                 </a:solidFill>
                 <a:latin typeface="Calibri"/>
               </a:rPr>
-              <a:t>@AmanDeepSrivastava19</a:t>
-            </a:r>
-          </a:p>
-        </p:txBody>
-      </p:sp>
-      <p:sp>
-        <p:nvSpPr>
-          <p:cNvPr id="79" name="TextBox 78"/>
-          <p:cNvSpPr txBox="1"/>
-          <p:nvPr/>
-        </p:nvSpPr>
-        <p:spPr>
-          <a:xfrm>
-            <a:off x="10469879" y="5010912"/>
-            <a:ext cx="1572768" cy="219456"/>
-          </a:xfrm>
-          <a:prstGeom prst="rect">
-            <a:avLst/>
-          </a:prstGeom>
-          <a:noFill/>
-        </p:spPr>
-        <p:txBody>
-          <a:bodyPr wrap="none">
+              <a:t>Aman Deep</a:t>
+            </a:r>
+          </a:p>
+        </p:txBody>
+      </p:sp>
+      <p:sp>
+        <p:nvSpPr>
+          <p:cNvPr id="103" name="TextBox 102"/>
+          <p:cNvSpPr txBox="1"/>
+          <p:nvPr/>
+        </p:nvSpPr>
+        <p:spPr>
+          <a:xfrm>
+            <a:off x="10360152" y="4965192"/>
+            <a:ext cx="822960" cy="201168"/>
+          </a:xfrm>
+          <a:prstGeom prst="rect">
+            <a:avLst/>
+          </a:prstGeom>
+          <a:noFill/>
+        </p:spPr>
+        <p:txBody>
+          <a:bodyPr wrap="square">
             <a:spAutoFit/>
           </a:bodyPr>
           <a:lstStyle/>
           <a:p>
             <a:pPr algn="l"/>
             <a:r>
-              <a:rPr sz="850" b="0" i="0">
+              <a:rPr sz="850" b="1" i="0">
+                <a:solidFill>
+                  <a:srgbClr val="FFC107"/>
+                </a:solidFill>
+                <a:latin typeface="Calibri"/>
+              </a:rPr>
+              <a:t>✦ Claude</a:t>
+            </a:r>
+          </a:p>
+        </p:txBody>
+      </p:sp>
+      <p:sp>
+        <p:nvSpPr>
+          <p:cNvPr id="104" name="TextBox 103"/>
+          <p:cNvSpPr txBox="1"/>
+          <p:nvPr/>
+        </p:nvSpPr>
+        <p:spPr>
+          <a:xfrm>
+            <a:off x="11228832" y="4965192"/>
+            <a:ext cx="896112" cy="201168"/>
+          </a:xfrm>
+          <a:prstGeom prst="rect">
+            <a:avLst/>
+          </a:prstGeom>
+          <a:noFill/>
+        </p:spPr>
+        <p:txBody>
+          <a:bodyPr wrap="square">
+            <a:spAutoFit/>
+          </a:bodyPr>
+          <a:lstStyle/>
+          <a:p>
+            <a:pPr algn="l"/>
+            <a:r>
+              <a:rPr sz="750" b="0" i="0">
                 <a:solidFill>
                   <a:srgbClr val="B2CCE8"/>
                 </a:solidFill>
@@ -15637,14 +16563,14 @@
       </p:sp>
       <p:sp>
         <p:nvSpPr>
-          <p:cNvPr id="80" name="Rectangle 79"/>
+          <p:cNvPr id="105" name="Rectangle 104"/>
           <p:cNvSpPr/>
           <p:nvPr/>
         </p:nvSpPr>
         <p:spPr>
           <a:xfrm>
-            <a:off x="6492240" y="5257800"/>
-            <a:ext cx="5577840" cy="256032"/>
+            <a:off x="6565392" y="5184648"/>
+            <a:ext cx="5577840" cy="237744"/>
           </a:xfrm>
           <a:prstGeom prst="rect">
             <a:avLst/>
@@ -15680,14 +16606,14 @@
       </p:sp>
       <p:sp>
         <p:nvSpPr>
-          <p:cNvPr id="81" name="TextBox 80"/>
-          <p:cNvSpPr txBox="1"/>
-          <p:nvPr/>
-        </p:nvSpPr>
-        <p:spPr>
-          <a:xfrm>
-            <a:off x="6583680" y="5285232"/>
-            <a:ext cx="2423160" cy="219456"/>
+          <p:cNvPr id="106" name="TextBox 105"/>
+          <p:cNvSpPr txBox="1"/>
+          <p:nvPr/>
+        </p:nvSpPr>
+        <p:spPr>
+          <a:xfrm>
+            <a:off x="6656832" y="5212080"/>
+            <a:ext cx="2331720" cy="201168"/>
           </a:xfrm>
           <a:prstGeom prst="rect">
             <a:avLst/>
@@ -15702,7 +16628,7 @@
           <a:p>
             <a:pPr algn="l"/>
             <a:r>
-              <a:rPr sz="950" b="1" i="0">
+              <a:rPr sz="900" b="1" i="0">
                 <a:solidFill>
                   <a:srgbClr val="FFFFFF"/>
                 </a:solidFill>
@@ -15715,14 +16641,14 @@
       </p:sp>
       <p:sp>
         <p:nvSpPr>
-          <p:cNvPr id="82" name="TextBox 81"/>
-          <p:cNvSpPr txBox="1"/>
-          <p:nvPr/>
-        </p:nvSpPr>
-        <p:spPr>
-          <a:xfrm>
-            <a:off x="9034272" y="5285232"/>
-            <a:ext cx="1417320" cy="219456"/>
+          <p:cNvPr id="107" name="TextBox 106"/>
+          <p:cNvSpPr txBox="1"/>
+          <p:nvPr/>
+        </p:nvSpPr>
+        <p:spPr>
+          <a:xfrm>
+            <a:off x="9034272" y="5212080"/>
+            <a:ext cx="1280160" cy="201168"/>
           </a:xfrm>
           <a:prstGeom prst="rect">
             <a:avLst/>
@@ -15743,29 +16669,29 @@
                 </a:solidFill>
                 <a:latin typeface="Calibri"/>
               </a:rPr>
-              <a:t>@ArundeepKamboj</a:t>
-            </a:r>
-          </a:p>
-        </p:txBody>
-      </p:sp>
-      <p:sp>
-        <p:nvSpPr>
-          <p:cNvPr id="83" name="TextBox 82"/>
-          <p:cNvSpPr txBox="1"/>
-          <p:nvPr/>
-        </p:nvSpPr>
-        <p:spPr>
-          <a:xfrm>
-            <a:off x="10469879" y="5285232"/>
-            <a:ext cx="1572768" cy="219456"/>
-          </a:xfrm>
-          <a:prstGeom prst="rect">
-            <a:avLst/>
-          </a:prstGeom>
-          <a:noFill/>
-        </p:spPr>
-        <p:txBody>
-          <a:bodyPr wrap="none">
+              <a:t>Arundeep</a:t>
+            </a:r>
+          </a:p>
+        </p:txBody>
+      </p:sp>
+      <p:sp>
+        <p:nvSpPr>
+          <p:cNvPr id="108" name="TextBox 107"/>
+          <p:cNvSpPr txBox="1"/>
+          <p:nvPr/>
+        </p:nvSpPr>
+        <p:spPr>
+          <a:xfrm>
+            <a:off x="10360152" y="5212080"/>
+            <a:ext cx="822960" cy="201168"/>
+          </a:xfrm>
+          <a:prstGeom prst="rect">
+            <a:avLst/>
+          </a:prstGeom>
+          <a:noFill/>
+        </p:spPr>
+        <p:txBody>
+          <a:bodyPr wrap="square">
             <a:spAutoFit/>
           </a:bodyPr>
           <a:lstStyle/>
@@ -15778,6 +16704,41 @@
                 </a:solidFill>
                 <a:latin typeface="Calibri"/>
               </a:rPr>
+              <a:t>solo</a:t>
+            </a:r>
+          </a:p>
+        </p:txBody>
+      </p:sp>
+      <p:sp>
+        <p:nvSpPr>
+          <p:cNvPr id="109" name="TextBox 108"/>
+          <p:cNvSpPr txBox="1"/>
+          <p:nvPr/>
+        </p:nvSpPr>
+        <p:spPr>
+          <a:xfrm>
+            <a:off x="11228832" y="5212080"/>
+            <a:ext cx="896112" cy="201168"/>
+          </a:xfrm>
+          <a:prstGeom prst="rect">
+            <a:avLst/>
+          </a:prstGeom>
+          <a:noFill/>
+        </p:spPr>
+        <p:txBody>
+          <a:bodyPr wrap="square">
+            <a:spAutoFit/>
+          </a:bodyPr>
+          <a:lstStyle/>
+          <a:p>
+            <a:pPr algn="l"/>
+            <a:r>
+              <a:rPr sz="750" b="0" i="0">
+                <a:solidFill>
+                  <a:srgbClr val="B2CCE8"/>
+                </a:solidFill>
+                <a:latin typeface="Calibri"/>
+              </a:rPr>
               <a:t>WCAG AAA colour palette</a:t>
             </a:r>
           </a:p>
@@ -15785,14 +16746,14 @@
       </p:sp>
       <p:sp>
         <p:nvSpPr>
-          <p:cNvPr id="84" name="Rectangle 83"/>
+          <p:cNvPr id="110" name="Rectangle 109"/>
           <p:cNvSpPr/>
           <p:nvPr/>
         </p:nvSpPr>
         <p:spPr>
           <a:xfrm>
-            <a:off x="6492240" y="5532120"/>
-            <a:ext cx="5577840" cy="256032"/>
+            <a:off x="6565392" y="5431536"/>
+            <a:ext cx="5577840" cy="237744"/>
           </a:xfrm>
           <a:prstGeom prst="rect">
             <a:avLst/>
@@ -15828,14 +16789,14 @@
       </p:sp>
       <p:sp>
         <p:nvSpPr>
-          <p:cNvPr id="85" name="TextBox 84"/>
-          <p:cNvSpPr txBox="1"/>
-          <p:nvPr/>
-        </p:nvSpPr>
-        <p:spPr>
-          <a:xfrm>
-            <a:off x="6583680" y="5559552"/>
-            <a:ext cx="2423160" cy="219456"/>
+          <p:cNvPr id="111" name="TextBox 110"/>
+          <p:cNvSpPr txBox="1"/>
+          <p:nvPr/>
+        </p:nvSpPr>
+        <p:spPr>
+          <a:xfrm>
+            <a:off x="6656832" y="5458968"/>
+            <a:ext cx="2331720" cy="201168"/>
           </a:xfrm>
           <a:prstGeom prst="rect">
             <a:avLst/>
@@ -15850,7 +16811,7 @@
           <a:p>
             <a:pPr algn="l"/>
             <a:r>
-              <a:rPr sz="950" b="1" i="0">
+              <a:rPr sz="900" b="1" i="0">
                 <a:solidFill>
                   <a:srgbClr val="FFFFFF"/>
                 </a:solidFill>
@@ -15863,14 +16824,14 @@
       </p:sp>
       <p:sp>
         <p:nvSpPr>
-          <p:cNvPr id="86" name="TextBox 85"/>
-          <p:cNvSpPr txBox="1"/>
-          <p:nvPr/>
-        </p:nvSpPr>
-        <p:spPr>
-          <a:xfrm>
-            <a:off x="9034272" y="5559552"/>
-            <a:ext cx="1417320" cy="219456"/>
+          <p:cNvPr id="112" name="TextBox 111"/>
+          <p:cNvSpPr txBox="1"/>
+          <p:nvPr/>
+        </p:nvSpPr>
+        <p:spPr>
+          <a:xfrm>
+            <a:off x="9034272" y="5458968"/>
+            <a:ext cx="1280160" cy="201168"/>
           </a:xfrm>
           <a:prstGeom prst="rect">
             <a:avLst/>
@@ -15891,29 +16852,29 @@
                 </a:solidFill>
                 <a:latin typeface="Calibri"/>
               </a:rPr>
-              <a:t>@ArundeepKamboj</a:t>
-            </a:r>
-          </a:p>
-        </p:txBody>
-      </p:sp>
-      <p:sp>
-        <p:nvSpPr>
-          <p:cNvPr id="87" name="TextBox 86"/>
-          <p:cNvSpPr txBox="1"/>
-          <p:nvPr/>
-        </p:nvSpPr>
-        <p:spPr>
-          <a:xfrm>
-            <a:off x="10469879" y="5559552"/>
-            <a:ext cx="1572768" cy="219456"/>
-          </a:xfrm>
-          <a:prstGeom prst="rect">
-            <a:avLst/>
-          </a:prstGeom>
-          <a:noFill/>
-        </p:spPr>
-        <p:txBody>
-          <a:bodyPr wrap="none">
+              <a:t>Arundeep</a:t>
+            </a:r>
+          </a:p>
+        </p:txBody>
+      </p:sp>
+      <p:sp>
+        <p:nvSpPr>
+          <p:cNvPr id="113" name="TextBox 112"/>
+          <p:cNvSpPr txBox="1"/>
+          <p:nvPr/>
+        </p:nvSpPr>
+        <p:spPr>
+          <a:xfrm>
+            <a:off x="10360152" y="5458968"/>
+            <a:ext cx="822960" cy="201168"/>
+          </a:xfrm>
+          <a:prstGeom prst="rect">
+            <a:avLst/>
+          </a:prstGeom>
+          <a:noFill/>
+        </p:spPr>
+        <p:txBody>
+          <a:bodyPr wrap="square">
             <a:spAutoFit/>
           </a:bodyPr>
           <a:lstStyle/>
@@ -15926,6 +16887,41 @@
                 </a:solidFill>
                 <a:latin typeface="Calibri"/>
               </a:rPr>
+              <a:t>solo</a:t>
+            </a:r>
+          </a:p>
+        </p:txBody>
+      </p:sp>
+      <p:sp>
+        <p:nvSpPr>
+          <p:cNvPr id="114" name="TextBox 113"/>
+          <p:cNvSpPr txBox="1"/>
+          <p:nvPr/>
+        </p:nvSpPr>
+        <p:spPr>
+          <a:xfrm>
+            <a:off x="11228832" y="5458968"/>
+            <a:ext cx="896112" cy="201168"/>
+          </a:xfrm>
+          <a:prstGeom prst="rect">
+            <a:avLst/>
+          </a:prstGeom>
+          <a:noFill/>
+        </p:spPr>
+        <p:txBody>
+          <a:bodyPr wrap="square">
+            <a:spAutoFit/>
+          </a:bodyPr>
+          <a:lstStyle/>
+          <a:p>
+            <a:pPr algn="l"/>
+            <a:r>
+              <a:rPr sz="750" b="0" i="0">
+                <a:solidFill>
+                  <a:srgbClr val="B2CCE8"/>
+                </a:solidFill>
+                <a:latin typeface="Calibri"/>
+              </a:rPr>
               <a:t>Navigation wiring</a:t>
             </a:r>
           </a:p>
@@ -15933,14 +16929,14 @@
       </p:sp>
       <p:sp>
         <p:nvSpPr>
-          <p:cNvPr id="88" name="Rectangle 87"/>
+          <p:cNvPr id="115" name="Rectangle 114"/>
           <p:cNvSpPr/>
           <p:nvPr/>
         </p:nvSpPr>
         <p:spPr>
           <a:xfrm>
-            <a:off x="6492240" y="5806440"/>
-            <a:ext cx="5577840" cy="256032"/>
+            <a:off x="6565392" y="5678424"/>
+            <a:ext cx="5577840" cy="237744"/>
           </a:xfrm>
           <a:prstGeom prst="rect">
             <a:avLst/>
@@ -15976,14 +16972,14 @@
       </p:sp>
       <p:sp>
         <p:nvSpPr>
-          <p:cNvPr id="89" name="TextBox 88"/>
-          <p:cNvSpPr txBox="1"/>
-          <p:nvPr/>
-        </p:nvSpPr>
-        <p:spPr>
-          <a:xfrm>
-            <a:off x="6583680" y="5833872"/>
-            <a:ext cx="2423160" cy="219456"/>
+          <p:cNvPr id="116" name="TextBox 115"/>
+          <p:cNvSpPr txBox="1"/>
+          <p:nvPr/>
+        </p:nvSpPr>
+        <p:spPr>
+          <a:xfrm>
+            <a:off x="6656832" y="5705856"/>
+            <a:ext cx="2331720" cy="201168"/>
           </a:xfrm>
           <a:prstGeom prst="rect">
             <a:avLst/>
@@ -15998,7 +16994,7 @@
           <a:p>
             <a:pPr algn="l"/>
             <a:r>
-              <a:rPr sz="950" b="1" i="0">
+              <a:rPr sz="900" b="1" i="0">
                 <a:solidFill>
                   <a:srgbClr val="FFFFFF"/>
                 </a:solidFill>
@@ -16011,14 +17007,14 @@
       </p:sp>
       <p:sp>
         <p:nvSpPr>
-          <p:cNvPr id="90" name="TextBox 89"/>
-          <p:cNvSpPr txBox="1"/>
-          <p:nvPr/>
-        </p:nvSpPr>
-        <p:spPr>
-          <a:xfrm>
-            <a:off x="9034272" y="5833872"/>
-            <a:ext cx="1417320" cy="219456"/>
+          <p:cNvPr id="117" name="TextBox 116"/>
+          <p:cNvSpPr txBox="1"/>
+          <p:nvPr/>
+        </p:nvSpPr>
+        <p:spPr>
+          <a:xfrm>
+            <a:off x="9034272" y="5705856"/>
+            <a:ext cx="1280160" cy="201168"/>
           </a:xfrm>
           <a:prstGeom prst="rect">
             <a:avLst/>
@@ -16039,36 +17035,71 @@
                 </a:solidFill>
                 <a:latin typeface="Calibri"/>
               </a:rPr>
-              <a:t>@AmanDeepSrivastava19</a:t>
-            </a:r>
-          </a:p>
-        </p:txBody>
-      </p:sp>
-      <p:sp>
-        <p:nvSpPr>
-          <p:cNvPr id="91" name="TextBox 90"/>
-          <p:cNvSpPr txBox="1"/>
-          <p:nvPr/>
-        </p:nvSpPr>
-        <p:spPr>
-          <a:xfrm>
-            <a:off x="10469879" y="5833872"/>
-            <a:ext cx="1572768" cy="219456"/>
-          </a:xfrm>
-          <a:prstGeom prst="rect">
-            <a:avLst/>
-          </a:prstGeom>
-          <a:noFill/>
-        </p:spPr>
-        <p:txBody>
-          <a:bodyPr wrap="none">
+              <a:t>Aman Deep</a:t>
+            </a:r>
+          </a:p>
+        </p:txBody>
+      </p:sp>
+      <p:sp>
+        <p:nvSpPr>
+          <p:cNvPr id="118" name="TextBox 117"/>
+          <p:cNvSpPr txBox="1"/>
+          <p:nvPr/>
+        </p:nvSpPr>
+        <p:spPr>
+          <a:xfrm>
+            <a:off x="10360152" y="5705856"/>
+            <a:ext cx="822960" cy="201168"/>
+          </a:xfrm>
+          <a:prstGeom prst="rect">
+            <a:avLst/>
+          </a:prstGeom>
+          <a:noFill/>
+        </p:spPr>
+        <p:txBody>
+          <a:bodyPr wrap="square">
             <a:spAutoFit/>
           </a:bodyPr>
           <a:lstStyle/>
           <a:p>
             <a:pPr algn="l"/>
             <a:r>
-              <a:rPr sz="850" b="0" i="0">
+              <a:rPr sz="850" b="1" i="0">
+                <a:solidFill>
+                  <a:srgbClr val="FFC107"/>
+                </a:solidFill>
+                <a:latin typeface="Calibri"/>
+              </a:rPr>
+              <a:t>✦ Claude</a:t>
+            </a:r>
+          </a:p>
+        </p:txBody>
+      </p:sp>
+      <p:sp>
+        <p:nvSpPr>
+          <p:cNvPr id="119" name="TextBox 118"/>
+          <p:cNvSpPr txBox="1"/>
+          <p:nvPr/>
+        </p:nvSpPr>
+        <p:spPr>
+          <a:xfrm>
+            <a:off x="11228832" y="5705856"/>
+            <a:ext cx="896112" cy="201168"/>
+          </a:xfrm>
+          <a:prstGeom prst="rect">
+            <a:avLst/>
+          </a:prstGeom>
+          <a:noFill/>
+        </p:spPr>
+        <p:txBody>
+          <a:bodyPr wrap="square">
+            <a:spAutoFit/>
+          </a:bodyPr>
+          <a:lstStyle/>
+          <a:p>
+            <a:pPr algn="l"/>
+            <a:r>
+              <a:rPr sz="750" b="0" i="0">
                 <a:solidFill>
                   <a:srgbClr val="B2CCE8"/>
                 </a:solidFill>
@@ -16081,14 +17112,14 @@
       </p:sp>
       <p:sp>
         <p:nvSpPr>
-          <p:cNvPr id="92" name="Rectangle 91"/>
+          <p:cNvPr id="120" name="Rectangle 119"/>
           <p:cNvSpPr/>
           <p:nvPr/>
         </p:nvSpPr>
         <p:spPr>
           <a:xfrm>
-            <a:off x="6492240" y="6080760"/>
-            <a:ext cx="5577840" cy="256032"/>
+            <a:off x="6565392" y="5925312"/>
+            <a:ext cx="5577840" cy="237744"/>
           </a:xfrm>
           <a:prstGeom prst="rect">
             <a:avLst/>
@@ -16124,14 +17155,14 @@
       </p:sp>
       <p:sp>
         <p:nvSpPr>
-          <p:cNvPr id="93" name="TextBox 92"/>
-          <p:cNvSpPr txBox="1"/>
-          <p:nvPr/>
-        </p:nvSpPr>
-        <p:spPr>
-          <a:xfrm>
-            <a:off x="6583680" y="6108192"/>
-            <a:ext cx="2423160" cy="219456"/>
+          <p:cNvPr id="121" name="TextBox 120"/>
+          <p:cNvSpPr txBox="1"/>
+          <p:nvPr/>
+        </p:nvSpPr>
+        <p:spPr>
+          <a:xfrm>
+            <a:off x="6656832" y="5952744"/>
+            <a:ext cx="2331720" cy="201168"/>
           </a:xfrm>
           <a:prstGeom prst="rect">
             <a:avLst/>
@@ -16146,27 +17177,27 @@
           <a:p>
             <a:pPr algn="l"/>
             <a:r>
-              <a:rPr sz="950" b="1" i="0">
+              <a:rPr sz="900" b="1" i="0">
                 <a:solidFill>
                   <a:srgbClr val="FFFFFF"/>
                 </a:solidFill>
                 <a:latin typeface="Calibri"/>
               </a:rPr>
-              <a:t>web/index.html</a:t>
-            </a:r>
-          </a:p>
-        </p:txBody>
-      </p:sp>
-      <p:sp>
-        <p:nvSpPr>
-          <p:cNvPr id="94" name="TextBox 93"/>
-          <p:cNvSpPr txBox="1"/>
-          <p:nvPr/>
-        </p:nvSpPr>
-        <p:spPr>
-          <a:xfrm>
-            <a:off x="9034272" y="6108192"/>
-            <a:ext cx="1417320" cy="219456"/>
+              <a:t>web/styles.css</a:t>
+            </a:r>
+          </a:p>
+        </p:txBody>
+      </p:sp>
+      <p:sp>
+        <p:nvSpPr>
+          <p:cNvPr id="122" name="TextBox 121"/>
+          <p:cNvSpPr txBox="1"/>
+          <p:nvPr/>
+        </p:nvSpPr>
+        <p:spPr>
+          <a:xfrm>
+            <a:off x="9034272" y="5952744"/>
+            <a:ext cx="1280160" cy="201168"/>
           </a:xfrm>
           <a:prstGeom prst="rect">
             <a:avLst/>
@@ -16187,56 +17218,91 @@
                 </a:solidFill>
                 <a:latin typeface="Calibri"/>
               </a:rPr>
-              <a:t>@AmanDeepSrivastava19</a:t>
-            </a:r>
-          </a:p>
-        </p:txBody>
-      </p:sp>
-      <p:sp>
-        <p:nvSpPr>
-          <p:cNvPr id="95" name="TextBox 94"/>
-          <p:cNvSpPr txBox="1"/>
-          <p:nvPr/>
-        </p:nvSpPr>
-        <p:spPr>
-          <a:xfrm>
-            <a:off x="10469879" y="6108192"/>
-            <a:ext cx="1572768" cy="219456"/>
-          </a:xfrm>
-          <a:prstGeom prst="rect">
-            <a:avLst/>
-          </a:prstGeom>
-          <a:noFill/>
-        </p:spPr>
-        <p:txBody>
-          <a:bodyPr wrap="none">
+              <a:t>Aman Deep</a:t>
+            </a:r>
+          </a:p>
+        </p:txBody>
+      </p:sp>
+      <p:sp>
+        <p:nvSpPr>
+          <p:cNvPr id="123" name="TextBox 122"/>
+          <p:cNvSpPr txBox="1"/>
+          <p:nvPr/>
+        </p:nvSpPr>
+        <p:spPr>
+          <a:xfrm>
+            <a:off x="10360152" y="5952744"/>
+            <a:ext cx="822960" cy="201168"/>
+          </a:xfrm>
+          <a:prstGeom prst="rect">
+            <a:avLst/>
+          </a:prstGeom>
+          <a:noFill/>
+        </p:spPr>
+        <p:txBody>
+          <a:bodyPr wrap="square">
             <a:spAutoFit/>
           </a:bodyPr>
           <a:lstStyle/>
           <a:p>
             <a:pPr algn="l"/>
             <a:r>
-              <a:rPr sz="850" b="0" i="0">
+              <a:rPr sz="850" b="1" i="0">
+                <a:solidFill>
+                  <a:srgbClr val="FFC107"/>
+                </a:solidFill>
+                <a:latin typeface="Calibri"/>
+              </a:rPr>
+              <a:t>✦ Claude</a:t>
+            </a:r>
+          </a:p>
+        </p:txBody>
+      </p:sp>
+      <p:sp>
+        <p:nvSpPr>
+          <p:cNvPr id="124" name="TextBox 123"/>
+          <p:cNvSpPr txBox="1"/>
+          <p:nvPr/>
+        </p:nvSpPr>
+        <p:spPr>
+          <a:xfrm>
+            <a:off x="11228832" y="5952744"/>
+            <a:ext cx="896112" cy="201168"/>
+          </a:xfrm>
+          <a:prstGeom prst="rect">
+            <a:avLst/>
+          </a:prstGeom>
+          <a:noFill/>
+        </p:spPr>
+        <p:txBody>
+          <a:bodyPr wrap="square">
+            <a:spAutoFit/>
+          </a:bodyPr>
+          <a:lstStyle/>
+          <a:p>
+            <a:pPr algn="l"/>
+            <a:r>
+              <a:rPr sz="750" b="0" i="0">
                 <a:solidFill>
                   <a:srgbClr val="B2CCE8"/>
                 </a:solidFill>
                 <a:latin typeface="Calibri"/>
               </a:rPr>
-              <a:t>Mic-bar HTML restructure</a:t>
-            </a:r>
-          </a:p>
-        </p:txBody>
-      </p:sp>
-      <p:sp>
-        <p:nvSpPr>
-          <p:cNvPr id="96" name="Rectangle 95"/>
+              <a:t>WCAG design system, mic-bar CSS</a:t>
+            </a:r>
+          </a:p>
+        </p:txBody>
+      </p:sp>
+      <p:sp>
+        <p:nvSpPr>
+          <p:cNvPr id="125" name="Rectangle 124"/>
           <p:cNvSpPr/>
           <p:nvPr/>
         </p:nvSpPr>
         <p:spPr>
           <a:xfrm>
-            <a:off x="6492240" y="6355080"/>
-            <a:ext cx="5577840" cy="256032"/>
+            <a:off x="6565392" y="6172200"/>
+            <a:ext cx="5577840" cy="237744"/>
           </a:xfrm>
           <a:prstGeom prst="rect">
             <a:avLst/>
@@ -16272,14 +17338,14 @@
       </p:sp>
       <p:sp>
         <p:nvSpPr>
-          <p:cNvPr id="97" name="TextBox 96"/>
-          <p:cNvSpPr txBox="1"/>
-          <p:nvPr/>
-        </p:nvSpPr>
-        <p:spPr>
-          <a:xfrm>
-            <a:off x="6583680" y="6382512"/>
-            <a:ext cx="2423160" cy="219456"/>
+          <p:cNvPr id="126" name="TextBox 125"/>
+          <p:cNvSpPr txBox="1"/>
+          <p:nvPr/>
+        </p:nvSpPr>
+        <p:spPr>
+          <a:xfrm>
+            <a:off x="6656832" y="6199632"/>
+            <a:ext cx="2331720" cy="201168"/>
           </a:xfrm>
           <a:prstGeom prst="rect">
             <a:avLst/>
@@ -16294,27 +17360,27 @@
           <a:p>
             <a:pPr algn="l"/>
             <a:r>
-              <a:rPr sz="950" b="1" i="0">
+              <a:rPr sz="900" b="1" i="0">
                 <a:solidFill>
                   <a:srgbClr val="FFFFFF"/>
                 </a:solidFill>
                 <a:latin typeface="Calibri"/>
               </a:rPr>
-              <a:t>web/styles.css</a:t>
-            </a:r>
-          </a:p>
-        </p:txBody>
-      </p:sp>
-      <p:sp>
-        <p:nvSpPr>
-          <p:cNvPr id="98" name="TextBox 97"/>
-          <p:cNvSpPr txBox="1"/>
-          <p:nvPr/>
-        </p:nvSpPr>
-        <p:spPr>
-          <a:xfrm>
-            <a:off x="9034272" y="6382512"/>
-            <a:ext cx="1417320" cy="219456"/>
+              <a:t>PROMPT_DOCUMENT.md</a:t>
+            </a:r>
+          </a:p>
+        </p:txBody>
+      </p:sp>
+      <p:sp>
+        <p:nvSpPr>
+          <p:cNvPr id="127" name="TextBox 126"/>
+          <p:cNvSpPr txBox="1"/>
+          <p:nvPr/>
+        </p:nvSpPr>
+        <p:spPr>
+          <a:xfrm>
+            <a:off x="9034272" y="6199632"/>
+            <a:ext cx="1280160" cy="201168"/>
           </a:xfrm>
           <a:prstGeom prst="rect">
             <a:avLst/>
@@ -16331,60 +17397,130 @@
             <a:r>
               <a:rPr sz="900" b="0" i="1">
                 <a:solidFill>
-                  <a:srgbClr val="4D9EFF"/>
-                </a:solidFill>
-                <a:latin typeface="Calibri"/>
-              </a:rPr>
-              <a:t>@AmanDeepSrivastava19</a:t>
-            </a:r>
-          </a:p>
-        </p:txBody>
-      </p:sp>
-      <p:sp>
-        <p:nvSpPr>
-          <p:cNvPr id="99" name="TextBox 98"/>
-          <p:cNvSpPr txBox="1"/>
-          <p:nvPr/>
-        </p:nvSpPr>
-        <p:spPr>
-          <a:xfrm>
-            <a:off x="10469879" y="6382512"/>
-            <a:ext cx="1572768" cy="219456"/>
-          </a:xfrm>
-          <a:prstGeom prst="rect">
-            <a:avLst/>
-          </a:prstGeom>
-          <a:noFill/>
-        </p:spPr>
-        <p:txBody>
-          <a:bodyPr wrap="none">
+                  <a:srgbClr val="AB47BC"/>
+                </a:solidFill>
+                <a:latin typeface="Calibri"/>
+              </a:rPr>
+              <a:t>Aman Deep</a:t>
+            </a:r>
+          </a:p>
+        </p:txBody>
+      </p:sp>
+      <p:sp>
+        <p:nvSpPr>
+          <p:cNvPr id="128" name="TextBox 127"/>
+          <p:cNvSpPr txBox="1"/>
+          <p:nvPr/>
+        </p:nvSpPr>
+        <p:spPr>
+          <a:xfrm>
+            <a:off x="10360152" y="6199632"/>
+            <a:ext cx="822960" cy="201168"/>
+          </a:xfrm>
+          <a:prstGeom prst="rect">
+            <a:avLst/>
+          </a:prstGeom>
+          <a:noFill/>
+        </p:spPr>
+        <p:txBody>
+          <a:bodyPr wrap="square">
             <a:spAutoFit/>
           </a:bodyPr>
           <a:lstStyle/>
           <a:p>
             <a:pPr algn="l"/>
             <a:r>
-              <a:rPr sz="850" b="0" i="0">
+              <a:rPr sz="850" b="1" i="0">
+                <a:solidFill>
+                  <a:srgbClr val="FFC107"/>
+                </a:solidFill>
+                <a:latin typeface="Calibri"/>
+              </a:rPr>
+              <a:t>✦ Claude</a:t>
+            </a:r>
+          </a:p>
+        </p:txBody>
+      </p:sp>
+      <p:sp>
+        <p:nvSpPr>
+          <p:cNvPr id="129" name="TextBox 128"/>
+          <p:cNvSpPr txBox="1"/>
+          <p:nvPr/>
+        </p:nvSpPr>
+        <p:spPr>
+          <a:xfrm>
+            <a:off x="11228832" y="6199632"/>
+            <a:ext cx="896112" cy="201168"/>
+          </a:xfrm>
+          <a:prstGeom prst="rect">
+            <a:avLst/>
+          </a:prstGeom>
+          <a:noFill/>
+        </p:spPr>
+        <p:txBody>
+          <a:bodyPr wrap="square">
+            <a:spAutoFit/>
+          </a:bodyPr>
+          <a:lstStyle/>
+          <a:p>
+            <a:pPr algn="l"/>
+            <a:r>
+              <a:rPr sz="750" b="0" i="0">
                 <a:solidFill>
                   <a:srgbClr val="B2CCE8"/>
                 </a:solidFill>
                 <a:latin typeface="Calibri"/>
               </a:rPr>
-              <a:t>WCAG design system, mic-bar CSS</a:t>
-            </a:r>
-          </a:p>
-        </p:txBody>
-      </p:sp>
-      <p:sp>
-        <p:nvSpPr>
-          <p:cNvPr id="100" name="Rectangle 99"/>
+              <a:t>Full project brief &amp; prompt history</a:t>
+            </a:r>
+          </a:p>
+        </p:txBody>
+      </p:sp>
+      <p:sp>
+        <p:nvSpPr>
+          <p:cNvPr id="130" name="TextBox 129"/>
+          <p:cNvSpPr txBox="1"/>
+          <p:nvPr/>
+        </p:nvSpPr>
+        <p:spPr>
+          <a:xfrm>
+            <a:off x="6565392" y="6455664"/>
+            <a:ext cx="5577840" cy="219456"/>
+          </a:xfrm>
+          <a:prstGeom prst="rect">
+            <a:avLst/>
+          </a:prstGeom>
+          <a:noFill/>
+        </p:spPr>
+        <p:txBody>
+          <a:bodyPr wrap="square">
+            <a:spAutoFit/>
+          </a:bodyPr>
+          <a:lstStyle/>
+          <a:p>
+            <a:pPr algn="l"/>
+            <a:r>
+              <a:rPr sz="850" b="0" i="1">
+                <a:solidFill>
+                  <a:srgbClr val="FFC107"/>
+                </a:solidFill>
+                <a:latin typeface="Calibri"/>
+              </a:rPr>
+              <a:t>✦ Claude  =  Aman Deep prompted and directed; Claude Sonnet 4.6 co-authored the implementation</a:t>
+            </a:r>
+          </a:p>
+        </p:txBody>
+      </p:sp>
+      <p:sp>
+        <p:nvSpPr>
+          <p:cNvPr id="131" name="Rectangle 130"/>
           <p:cNvSpPr/>
           <p:nvPr/>
         </p:nvSpPr>
         <p:spPr>
           <a:xfrm>
-            <a:off x="347472" y="6510528"/>
-            <a:ext cx="11521440" cy="274320"/>
+            <a:off x="347472" y="6675120"/>
+            <a:ext cx="11521440" cy="182880"/>
           </a:xfrm>
           <a:prstGeom prst="rect">
             <a:avLst/>
@@ -16420,35 +17556,35 @@
       </p:sp>
       <p:sp>
         <p:nvSpPr>
-          <p:cNvPr id="101" name="TextBox 100"/>
-          <p:cNvSpPr txBox="1"/>
-          <p:nvPr/>
-        </p:nvSpPr>
-        <p:spPr>
-          <a:xfrm>
-            <a:off x="457200" y="6528816"/>
-            <a:ext cx="11247120" cy="237744"/>
-          </a:xfrm>
-          <a:prstGeom prst="rect">
-            <a:avLst/>
-          </a:prstGeom>
-          <a:noFill/>
-        </p:spPr>
-        <p:txBody>
-          <a:bodyPr wrap="square">
-            <a:spAutoFit/>
-          </a:bodyPr>
-          <a:lstStyle/>
-          <a:p>
-            <a:pPr algn="ctr"/>
-            <a:r>
-              <a:rPr sz="950" b="0" i="0">
+          <p:cNvPr id="132" name="TextBox 131"/>
+          <p:cNvSpPr txBox="1"/>
+          <p:nvPr/>
+        </p:nvSpPr>
+        <p:spPr>
+          <a:xfrm>
+            <a:off x="457200" y="6693408"/>
+            <a:ext cx="11247120" cy="146304"/>
+          </a:xfrm>
+          <a:prstGeom prst="rect">
+            <a:avLst/>
+          </a:prstGeom>
+          <a:noFill/>
+        </p:spPr>
+        <p:txBody>
+          <a:bodyPr wrap="square">
+            <a:spAutoFit/>
+          </a:bodyPr>
+          <a:lstStyle/>
+          <a:p>
+            <a:pPr algn="ctr"/>
+            <a:r>
+              <a:rPr sz="900" b="0" i="0">
                 <a:solidFill>
                   <a:srgbClr val="B2CCE8"/>
                 </a:solidFill>
                 <a:latin typeface="Calibri"/>
               </a:rPr>
-              <a:t>Repository: github.com/esfaihackathon/visual-assistant-ai  •  Branch: main  •  35 commits total</a:t>
+              <a:t>github.com/esfaihackathon/visual-assistant-ai  ·  branch: main  ·  35 commits total</a:t>
             </a:r>
           </a:p>
         </p:txBody>

</xml_diff>

<commit_message>
Update business deck: add Sukamal Maity commit attribution and PPT contribution
- Sukamal's commit count updated from — to 1 (this business deck commit)
- Contributor note updated: business deck & contributor attribution
- Footer total: 35 → 36 commits
- Badge now shows numeric count with filled colour (no more empty dash)

Co-Authored-By: Sukamal Maity <SukamalMaity@users.noreply.github.com>
</commit_message>
<xml_diff>
--- a/presentation/Saral-Business-Deck.pptx
+++ b/presentation/Saral-Business-Deck.pptx
@@ -14678,11 +14678,11 @@
             <a:r>
               <a:rPr sz="1400" b="1" i="0">
                 <a:solidFill>
-                  <a:srgbClr val="FFFFFF"/>
-                </a:solidFill>
-                <a:latin typeface="Calibri"/>
-              </a:rPr>
-              <a:t>—</a:t>
+                  <a:srgbClr val="040C18"/>
+                </a:solidFill>
+                <a:latin typeface="Calibri"/>
+              </a:rPr>
+              <a:t>1</a:t>
             </a:r>
           </a:p>
         </p:txBody>
@@ -14752,7 +14752,7 @@
                 </a:solidFill>
                 <a:latin typeface="Calibri"/>
               </a:rPr>
-              <a:t>@SukamalMaity  ·  Product strategy &amp; UX review</a:t>
+              <a:t>@SukamalMaity  ·  1 commit  ·  business deck &amp; contributor attribution</a:t>
             </a:r>
           </a:p>
         </p:txBody>
@@ -14788,7 +14788,7 @@
                 <a:latin typeface="Calibri"/>
               </a:rPr>
               <a:t>User research, accessibility requirement specification,
-stakeholder presentation, QA sign-off</a:t>
+stakeholder presentation, QA sign-off, business PPT</a:t>
             </a:r>
           </a:p>
         </p:txBody>
@@ -17584,7 +17584,7 @@
                 </a:solidFill>
                 <a:latin typeface="Calibri"/>
               </a:rPr>
-              <a:t>github.com/esfaihackathon/visual-assistant-ai  ·  branch: main  ·  35 commits total</a:t>
+              <a:t>github.com/esfaihackathon/visual-assistant-ai  ·  branch: main  ·  36 commits total</a:t>
             </a:r>
           </a:p>
         </p:txBody>

</xml_diff>